<commit_message>
Train custom SVM with INRIA dataset subset
</commit_message>
<xml_diff>
--- a/docs/Slide_HOG_SVM.pptx
+++ b/docs/Slide_HOG_SVM.pptx
@@ -2,24 +2,24 @@
 <file path=ppt/presentation.xml><?xml version="1.0" encoding="utf-8"?>
 <p:presentation xmlns:p="http://schemas.openxmlformats.org/presentationml/2006/main">
   <p:sldMasterIdLst>
-    <p:sldMasterId xmlns:r="http://schemas.openxmlformats.org/officeDocument/2006/relationships" id="2147483648" r:id="R2bc8fb01d1c2429e"/>
+    <p:sldMasterId xmlns:r="http://schemas.openxmlformats.org/officeDocument/2006/relationships" id="2147483648" r:id="R544883d44b0c4f7d"/>
   </p:sldMasterIdLst>
   <p:notesMasterIdLst>
-    <p:notesMasterId xmlns:r="http://schemas.openxmlformats.org/officeDocument/2006/relationships" r:id="R5288b51a28c34b3c"/>
+    <p:notesMasterId xmlns:r="http://schemas.openxmlformats.org/officeDocument/2006/relationships" r:id="Rd3e2f13cd8d741eb"/>
   </p:notesMasterIdLst>
   <p:sldIdLst>
-    <p:sldId xmlns:r="http://schemas.openxmlformats.org/officeDocument/2006/relationships" id="256" r:id="Rb97865c4e2bb4dbf"/>
-    <p:sldId xmlns:r="http://schemas.openxmlformats.org/officeDocument/2006/relationships" id="257" r:id="Rfd63423a803045d0"/>
-    <p:sldId xmlns:r="http://schemas.openxmlformats.org/officeDocument/2006/relationships" id="258" r:id="Rbc04c11c3ef8420c"/>
-    <p:sldId xmlns:r="http://schemas.openxmlformats.org/officeDocument/2006/relationships" id="259" r:id="Re1da566e7d39410e"/>
-    <p:sldId xmlns:r="http://schemas.openxmlformats.org/officeDocument/2006/relationships" id="260" r:id="R79dd9900216d45d1"/>
-    <p:sldId xmlns:r="http://schemas.openxmlformats.org/officeDocument/2006/relationships" id="261" r:id="R3950574c2c484c26"/>
-    <p:sldId xmlns:r="http://schemas.openxmlformats.org/officeDocument/2006/relationships" id="262" r:id="Rcc665c4785f34948"/>
-    <p:sldId xmlns:r="http://schemas.openxmlformats.org/officeDocument/2006/relationships" id="263" r:id="R6302e8eb153b4253"/>
-    <p:sldId xmlns:r="http://schemas.openxmlformats.org/officeDocument/2006/relationships" id="264" r:id="R2a5a033c2c694dcb"/>
-    <p:sldId xmlns:r="http://schemas.openxmlformats.org/officeDocument/2006/relationships" id="265" r:id="Re1a43cb877d84669"/>
-    <p:sldId xmlns:r="http://schemas.openxmlformats.org/officeDocument/2006/relationships" id="266" r:id="R5b46e4d3055a4687"/>
-    <p:sldId xmlns:r="http://schemas.openxmlformats.org/officeDocument/2006/relationships" id="267" r:id="R0db51e8554f64b2b"/>
+    <p:sldId xmlns:r="http://schemas.openxmlformats.org/officeDocument/2006/relationships" id="256" r:id="R373725d298d04ccb"/>
+    <p:sldId xmlns:r="http://schemas.openxmlformats.org/officeDocument/2006/relationships" id="257" r:id="R5faa1c039ef748b6"/>
+    <p:sldId xmlns:r="http://schemas.openxmlformats.org/officeDocument/2006/relationships" id="258" r:id="R06f34a6b34644967"/>
+    <p:sldId xmlns:r="http://schemas.openxmlformats.org/officeDocument/2006/relationships" id="259" r:id="Rc085249acb6145e0"/>
+    <p:sldId xmlns:r="http://schemas.openxmlformats.org/officeDocument/2006/relationships" id="260" r:id="Rdbe3f1df73164a98"/>
+    <p:sldId xmlns:r="http://schemas.openxmlformats.org/officeDocument/2006/relationships" id="261" r:id="R211e12908a95446e"/>
+    <p:sldId xmlns:r="http://schemas.openxmlformats.org/officeDocument/2006/relationships" id="262" r:id="R3d287824647e4dab"/>
+    <p:sldId xmlns:r="http://schemas.openxmlformats.org/officeDocument/2006/relationships" id="263" r:id="R2f2d9bf7a0e84233"/>
+    <p:sldId xmlns:r="http://schemas.openxmlformats.org/officeDocument/2006/relationships" id="264" r:id="R2a303e90a0e140d2"/>
+    <p:sldId xmlns:r="http://schemas.openxmlformats.org/officeDocument/2006/relationships" id="265" r:id="Raf2167ab5a81458d"/>
+    <p:sldId xmlns:r="http://schemas.openxmlformats.org/officeDocument/2006/relationships" id="266" r:id="Rd389f13f1ebc41e2"/>
+    <p:sldId xmlns:r="http://schemas.openxmlformats.org/officeDocument/2006/relationships" id="267" r:id="R01b3a9b5a95e4625"/>
   </p:sldIdLst>
   <p:sldSz cx="12192000" cy="6858000"/>
   <p:notesSz cx="6858000" cy="9144000"/>
@@ -1338,7 +1338,7 @@
   </p:cSld>
   <p:clrMap bg1="lt1" tx1="dk1" bg2="lt2" tx2="dk2" accent1="accent1" accent2="accent2" accent3="accent3" accent4="accent4" accent5="accent5" accent6="accent6" hlink="hlink" folHlink="folHlink"/>
   <p:sldLayoutIdLst>
-    <p:sldLayoutId xmlns:r="http://schemas.openxmlformats.org/officeDocument/2006/relationships" id="2147483649" r:id="Ref45e481bdd54e4d"/>
+    <p:sldLayoutId xmlns:r="http://schemas.openxmlformats.org/officeDocument/2006/relationships" id="2147483649" r:id="R3a1a3cb7bcfc4911"/>
   </p:sldLayoutIdLst>
   <p:txStyles>
     <p:titleStyle>
@@ -1889,7 +1889,7 @@
           <p:cNvPr id="1" name="">
             <a:extLst xmlns:a="http://schemas.openxmlformats.org/drawingml/2006/main">
               <a:ext uri="{FF2B5EF4-FFF2-40B4-BE49-F238E27FC236}">
-                <a16:creationId xmlns:a16="http://schemas.microsoft.com/office/drawing/2014/main" id="{ABF90BCF-A985-4423-86BF-ED29923EEE1C}"/>
+                <a16:creationId xmlns:a16="http://schemas.microsoft.com/office/drawing/2014/main" id="{3113DBD1-8A73-4C28-93A2-9BFF63C80C74}"/>
               </a:ext>
             </a:extLst>
           </p:cNvPr>
@@ -1939,7 +1939,7 @@
           <p:cNvPr id="2" name="">
             <a:extLst xmlns:a="http://schemas.openxmlformats.org/drawingml/2006/main">
               <a:ext uri="{FF2B5EF4-FFF2-40B4-BE49-F238E27FC236}">
-                <a16:creationId xmlns:a16="http://schemas.microsoft.com/office/drawing/2014/main" id="{95935440-1117-4A6B-BE33-3B9ED483B43C}"/>
+                <a16:creationId xmlns:a16="http://schemas.microsoft.com/office/drawing/2014/main" id="{3CB8B475-15C1-4A45-AD28-B23400C4854F}"/>
               </a:ext>
             </a:extLst>
           </p:cNvPr>
@@ -1989,7 +1989,7 @@
           <p:cNvPr id="3" name="">
             <a:extLst xmlns:a="http://schemas.openxmlformats.org/drawingml/2006/main">
               <a:ext uri="{FF2B5EF4-FFF2-40B4-BE49-F238E27FC236}">
-                <a16:creationId xmlns:a16="http://schemas.microsoft.com/office/drawing/2014/main" id="{3009A9F7-0C94-44FC-8FAA-5B856F7F96A3}"/>
+                <a16:creationId xmlns:a16="http://schemas.microsoft.com/office/drawing/2014/main" id="{D1719C8E-4CC5-4AD4-A0FB-37AE6BCF0653}"/>
               </a:ext>
             </a:extLst>
           </p:cNvPr>
@@ -2001,7 +2001,7 @@
         <p:spPr>
           <a:xfrm xmlns:a="http://schemas.openxmlformats.org/drawingml/2006/main">
             <a:off x="400050" y="3714750"/>
-            <a:ext cx="7429500" cy="400050"/>
+            <a:ext cx="8001000" cy="400050"/>
           </a:xfrm>
           <a:prstGeom xmlns:a="http://schemas.openxmlformats.org/drawingml/2006/main" prst="rect">
             <a:avLst/>
@@ -2029,7 +2029,7 @@
                   <a:srgbClr val="222222"/>
                 </a:solidFill>
               </a:rPr>
-              <a:t>Demo realtime trên video/webcam · Có custom Linear SVM tự train</a:t>
+              <a:t>Demo realtime trên video/webcam · Custom Linear SVM train từ INRIA subset</a:t>
             </a:r>
           </a:p>
         </p:txBody>
@@ -2039,7 +2039,7 @@
           <p:cNvPr id="4" name="">
             <a:extLst xmlns:a="http://schemas.openxmlformats.org/drawingml/2006/main">
               <a:ext uri="{FF2B5EF4-FFF2-40B4-BE49-F238E27FC236}">
-                <a16:creationId xmlns:a16="http://schemas.microsoft.com/office/drawing/2014/main" id="{93FECF88-A054-4B0B-AB2E-9A574A90E4E3}"/>
+                <a16:creationId xmlns:a16="http://schemas.microsoft.com/office/drawing/2014/main" id="{DF2A1E58-31C8-4DE7-A83C-7AADB444DC88}"/>
               </a:ext>
             </a:extLst>
           </p:cNvPr>
@@ -2072,7 +2072,7 @@
           <p:cNvPr id="5" name="">
             <a:extLst xmlns:a="http://schemas.openxmlformats.org/drawingml/2006/main">
               <a:ext uri="{FF2B5EF4-FFF2-40B4-BE49-F238E27FC236}">
-                <a16:creationId xmlns:a16="http://schemas.microsoft.com/office/drawing/2014/main" id="{805BA108-1244-4960-9813-CCFC8015A69C}"/>
+                <a16:creationId xmlns:a16="http://schemas.microsoft.com/office/drawing/2014/main" id="{DA2BF89A-2411-4410-81C1-0DD455749223}"/>
               </a:ext>
             </a:extLst>
           </p:cNvPr>
@@ -2156,7 +2156,7 @@
           <p:cNvPr id="6" name="">
             <a:extLst xmlns:a="http://schemas.openxmlformats.org/drawingml/2006/main">
               <a:ext uri="{FF2B5EF4-FFF2-40B4-BE49-F238E27FC236}">
-                <a16:creationId xmlns:a16="http://schemas.microsoft.com/office/drawing/2014/main" id="{D043EB8F-B145-4A75-9445-AC650D6ABD8B}"/>
+                <a16:creationId xmlns:a16="http://schemas.microsoft.com/office/drawing/2014/main" id="{CC8B9A1A-ED70-4779-A87C-359F973412C5}"/>
               </a:ext>
             </a:extLst>
           </p:cNvPr>
@@ -2204,7 +2204,7 @@
     </p:spTree>
     <p:extLst>
       <p:ext uri="{BB962C8B-B14F-4D97-AF65-F5344CB8AC3E}">
-        <p14:creationId xmlns:p14="http://schemas.microsoft.com/office/powerpoint/2010/main" val="1901986308"/>
+        <p14:creationId xmlns:p14="http://schemas.microsoft.com/office/powerpoint/2010/main" val="221211458"/>
       </p:ext>
     </p:extLst>
   </p:cSld>
@@ -2235,7 +2235,7 @@
           <p:cNvPr id="1" name="">
             <a:extLst xmlns:a="http://schemas.openxmlformats.org/drawingml/2006/main">
               <a:ext uri="{FF2B5EF4-FFF2-40B4-BE49-F238E27FC236}">
-                <a16:creationId xmlns:a16="http://schemas.microsoft.com/office/drawing/2014/main" id="{438B36B5-F9D2-4587-AE28-432233937978}"/>
+                <a16:creationId xmlns:a16="http://schemas.microsoft.com/office/drawing/2014/main" id="{1668B346-50D7-449F-9B90-EE7FF00772CB}"/>
               </a:ext>
             </a:extLst>
           </p:cNvPr>
@@ -2285,7 +2285,7 @@
           <p:cNvPr id="2" name="">
             <a:extLst xmlns:a="http://schemas.openxmlformats.org/drawingml/2006/main">
               <a:ext uri="{FF2B5EF4-FFF2-40B4-BE49-F238E27FC236}">
-                <a16:creationId xmlns:a16="http://schemas.microsoft.com/office/drawing/2014/main" id="{45C420C3-4455-450D-A462-FBB6BFCA77B4}"/>
+                <a16:creationId xmlns:a16="http://schemas.microsoft.com/office/drawing/2014/main" id="{326E3F6E-5606-4992-BE80-8BD35CC20FAC}"/>
               </a:ext>
             </a:extLst>
           </p:cNvPr>
@@ -2335,7 +2335,7 @@
           <p:cNvPr id="3" name="">
             <a:extLst xmlns:a="http://schemas.openxmlformats.org/drawingml/2006/main">
               <a:ext uri="{FF2B5EF4-FFF2-40B4-BE49-F238E27FC236}">
-                <a16:creationId xmlns:a16="http://schemas.microsoft.com/office/drawing/2014/main" id="{33CEA7D0-ED14-4B42-9968-ECDBA4552D3A}"/>
+                <a16:creationId xmlns:a16="http://schemas.microsoft.com/office/drawing/2014/main" id="{6ED43076-2087-4045-B689-60CF056FB28A}"/>
               </a:ext>
             </a:extLst>
           </p:cNvPr>
@@ -2368,7 +2368,7 @@
           <p:cNvPr id="4" name="">
             <a:extLst xmlns:a="http://schemas.openxmlformats.org/drawingml/2006/main">
               <a:ext uri="{FF2B5EF4-FFF2-40B4-BE49-F238E27FC236}">
-                <a16:creationId xmlns:a16="http://schemas.microsoft.com/office/drawing/2014/main" id="{35281ABC-F69B-4566-9FD9-7CAEC52BAED0}"/>
+                <a16:creationId xmlns:a16="http://schemas.microsoft.com/office/drawing/2014/main" id="{D43D5B55-8D7B-44AC-9960-FC68EF04F06D}"/>
               </a:ext>
             </a:extLst>
           </p:cNvPr>
@@ -2401,7 +2401,7 @@
           <p:cNvPr id="5" name="">
             <a:extLst xmlns:a="http://schemas.openxmlformats.org/drawingml/2006/main">
               <a:ext uri="{FF2B5EF4-FFF2-40B4-BE49-F238E27FC236}">
-                <a16:creationId xmlns:a16="http://schemas.microsoft.com/office/drawing/2014/main" id="{F03D0172-7C45-4C6B-9208-4CA4C4493587}"/>
+                <a16:creationId xmlns:a16="http://schemas.microsoft.com/office/drawing/2014/main" id="{3DA60C22-AE18-4272-90EB-BCA167259D9B}"/>
               </a:ext>
             </a:extLst>
           </p:cNvPr>
@@ -2441,7 +2441,7 @@
                   <a:srgbClr val="000000"/>
                 </a:solidFill>
               </a:rPr>
-              <a:t>python src/run_realtime.py --source dataset/videos/walking.mp4</a:t>
+              <a:t>python src/run_realtime.py --source path/to/video.mp4</a:t>
             </a:r>
           </a:p>
         </p:txBody>
@@ -2451,7 +2451,7 @@
           <p:cNvPr id="6" name="">
             <a:extLst xmlns:a="http://schemas.openxmlformats.org/drawingml/2006/main">
               <a:ext uri="{FF2B5EF4-FFF2-40B4-BE49-F238E27FC236}">
-                <a16:creationId xmlns:a16="http://schemas.microsoft.com/office/drawing/2014/main" id="{06F2D256-F5EF-4772-A480-BF62DB457E48}"/>
+                <a16:creationId xmlns:a16="http://schemas.microsoft.com/office/drawing/2014/main" id="{A079E306-D5F5-4D3B-B512-8BE11A2BF88B}"/>
               </a:ext>
             </a:extLst>
           </p:cNvPr>
@@ -2484,7 +2484,7 @@
           <p:cNvPr id="7" name="">
             <a:extLst xmlns:a="http://schemas.openxmlformats.org/drawingml/2006/main">
               <a:ext uri="{FF2B5EF4-FFF2-40B4-BE49-F238E27FC236}">
-                <a16:creationId xmlns:a16="http://schemas.microsoft.com/office/drawing/2014/main" id="{7E4FB572-0168-4302-AB3E-1ABD11353655}"/>
+                <a16:creationId xmlns:a16="http://schemas.microsoft.com/office/drawing/2014/main" id="{C12FBDC8-9F0D-4C6E-9D4B-DBF55D3018FF}"/>
               </a:ext>
             </a:extLst>
           </p:cNvPr>
@@ -2524,7 +2524,7 @@
                   <a:srgbClr val="000000"/>
                 </a:solidFill>
               </a:rPr>
-              <a:t>python src/run_realtime.py --source dataset/videos/walking.mp4 --model custom --custom-max-width 360 --custom-threshold 0.8</a:t>
+              <a:t>python src/run_realtime.py --source path/to/video.mp4 --model custom --custom-max-width 360 --custom-threshold 0.8</a:t>
             </a:r>
           </a:p>
         </p:txBody>
@@ -2534,7 +2534,7 @@
           <p:cNvPr id="8" name="">
             <a:extLst xmlns:a="http://schemas.openxmlformats.org/drawingml/2006/main">
               <a:ext uri="{FF2B5EF4-FFF2-40B4-BE49-F238E27FC236}">
-                <a16:creationId xmlns:a16="http://schemas.microsoft.com/office/drawing/2014/main" id="{274178EF-B7F8-47B6-AB2E-8E08742C8F0C}"/>
+                <a16:creationId xmlns:a16="http://schemas.microsoft.com/office/drawing/2014/main" id="{1EFFFA5E-FAD1-4711-ABE4-3AD14ED74F67}"/>
               </a:ext>
             </a:extLst>
           </p:cNvPr>
@@ -2582,7 +2582,7 @@
     </p:spTree>
     <p:extLst>
       <p:ext uri="{BB962C8B-B14F-4D97-AF65-F5344CB8AC3E}">
-        <p14:creationId xmlns:p14="http://schemas.microsoft.com/office/powerpoint/2010/main" val="1175273516"/>
+        <p14:creationId xmlns:p14="http://schemas.microsoft.com/office/powerpoint/2010/main" val="175565926"/>
       </p:ext>
     </p:extLst>
   </p:cSld>
@@ -2613,7 +2613,7 @@
           <p:cNvPr id="1" name="">
             <a:extLst xmlns:a="http://schemas.openxmlformats.org/drawingml/2006/main">
               <a:ext uri="{FF2B5EF4-FFF2-40B4-BE49-F238E27FC236}">
-                <a16:creationId xmlns:a16="http://schemas.microsoft.com/office/drawing/2014/main" id="{4639ABB1-248E-46B6-8C32-B220108CC4A0}"/>
+                <a16:creationId xmlns:a16="http://schemas.microsoft.com/office/drawing/2014/main" id="{D7183295-4C1B-420A-A65F-620EE18391A7}"/>
               </a:ext>
             </a:extLst>
           </p:cNvPr>
@@ -2663,7 +2663,7 @@
           <p:cNvPr id="2" name="">
             <a:extLst xmlns:a="http://schemas.openxmlformats.org/drawingml/2006/main">
               <a:ext uri="{FF2B5EF4-FFF2-40B4-BE49-F238E27FC236}">
-                <a16:creationId xmlns:a16="http://schemas.microsoft.com/office/drawing/2014/main" id="{44F00331-0ACA-43A1-AD77-E1DAEAB1322B}"/>
+                <a16:creationId xmlns:a16="http://schemas.microsoft.com/office/drawing/2014/main" id="{BBEB7AB2-A93E-422D-9D4A-DB62974378E3}"/>
               </a:ext>
             </a:extLst>
           </p:cNvPr>
@@ -2713,7 +2713,7 @@
           <p:cNvPr id="3" name="">
             <a:extLst xmlns:a="http://schemas.openxmlformats.org/drawingml/2006/main">
               <a:ext uri="{FF2B5EF4-FFF2-40B4-BE49-F238E27FC236}">
-                <a16:creationId xmlns:a16="http://schemas.microsoft.com/office/drawing/2014/main" id="{AA139AB0-5120-4827-A385-B67D98F44726}"/>
+                <a16:creationId xmlns:a16="http://schemas.microsoft.com/office/drawing/2014/main" id="{5FD5D020-3BC6-4804-9351-009D32DD83F0}"/>
               </a:ext>
             </a:extLst>
           </p:cNvPr>
@@ -2746,7 +2746,7 @@
           <p:cNvPr id="4" name="">
             <a:extLst xmlns:a="http://schemas.openxmlformats.org/drawingml/2006/main">
               <a:ext uri="{FF2B5EF4-FFF2-40B4-BE49-F238E27FC236}">
-                <a16:creationId xmlns:a16="http://schemas.microsoft.com/office/drawing/2014/main" id="{F0FA54A9-EC14-4486-9E53-A334FCA7C7F7}"/>
+                <a16:creationId xmlns:a16="http://schemas.microsoft.com/office/drawing/2014/main" id="{1207AEFF-46B8-454F-BB6D-F1B1A6831BB5}"/>
               </a:ext>
             </a:extLst>
           </p:cNvPr>
@@ -2779,7 +2779,7 @@
           <p:cNvPr id="5" name="">
             <a:extLst xmlns:a="http://schemas.openxmlformats.org/drawingml/2006/main">
               <a:ext uri="{FF2B5EF4-FFF2-40B4-BE49-F238E27FC236}">
-                <a16:creationId xmlns:a16="http://schemas.microsoft.com/office/drawing/2014/main" id="{47DD0687-C721-4CF5-B025-11A9FC58FF9D}"/>
+                <a16:creationId xmlns:a16="http://schemas.microsoft.com/office/drawing/2014/main" id="{30B9503C-C911-4F2B-9A50-F96D6B252CE2}"/>
               </a:ext>
             </a:extLst>
           </p:cNvPr>
@@ -2812,7 +2812,7 @@
           <p:cNvPr id="6" name="">
             <a:extLst xmlns:a="http://schemas.openxmlformats.org/drawingml/2006/main">
               <a:ext uri="{FF2B5EF4-FFF2-40B4-BE49-F238E27FC236}">
-                <a16:creationId xmlns:a16="http://schemas.microsoft.com/office/drawing/2014/main" id="{775FCB3E-5D09-40A4-8D50-3CB13020ADAA}"/>
+                <a16:creationId xmlns:a16="http://schemas.microsoft.com/office/drawing/2014/main" id="{E1B63C09-61D5-4148-8B07-42B45FAC8385}"/>
               </a:ext>
             </a:extLst>
           </p:cNvPr>
@@ -2862,7 +2862,7 @@
           <p:cNvPr id="7" name="">
             <a:extLst xmlns:a="http://schemas.openxmlformats.org/drawingml/2006/main">
               <a:ext uri="{FF2B5EF4-FFF2-40B4-BE49-F238E27FC236}">
-                <a16:creationId xmlns:a16="http://schemas.microsoft.com/office/drawing/2014/main" id="{58CE3291-4684-447F-83DC-9B82F3577697}"/>
+                <a16:creationId xmlns:a16="http://schemas.microsoft.com/office/drawing/2014/main" id="{709548B8-97A4-4738-917E-900E7BBAE766}"/>
               </a:ext>
             </a:extLst>
           </p:cNvPr>
@@ -2963,7 +2963,7 @@
           <p:cNvPr id="8" name="">
             <a:extLst xmlns:a="http://schemas.openxmlformats.org/drawingml/2006/main">
               <a:ext uri="{FF2B5EF4-FFF2-40B4-BE49-F238E27FC236}">
-                <a16:creationId xmlns:a16="http://schemas.microsoft.com/office/drawing/2014/main" id="{D29A2875-6EF9-4056-8C93-2FBA6E15EC79}"/>
+                <a16:creationId xmlns:a16="http://schemas.microsoft.com/office/drawing/2014/main" id="{8CC53109-8AFB-4E7B-A65C-AB25F9071412}"/>
               </a:ext>
             </a:extLst>
           </p:cNvPr>
@@ -3013,7 +3013,7 @@
           <p:cNvPr id="9" name="">
             <a:extLst xmlns:a="http://schemas.openxmlformats.org/drawingml/2006/main">
               <a:ext uri="{FF2B5EF4-FFF2-40B4-BE49-F238E27FC236}">
-                <a16:creationId xmlns:a16="http://schemas.microsoft.com/office/drawing/2014/main" id="{34E0CEDB-39AF-4CC7-B894-694934E08D69}"/>
+                <a16:creationId xmlns:a16="http://schemas.microsoft.com/office/drawing/2014/main" id="{563104A4-E4D4-49BE-9783-9848D8853C20}"/>
               </a:ext>
             </a:extLst>
           </p:cNvPr>
@@ -3114,7 +3114,7 @@
           <p:cNvPr id="10" name="">
             <a:extLst xmlns:a="http://schemas.openxmlformats.org/drawingml/2006/main">
               <a:ext uri="{FF2B5EF4-FFF2-40B4-BE49-F238E27FC236}">
-                <a16:creationId xmlns:a16="http://schemas.microsoft.com/office/drawing/2014/main" id="{47238F5A-88CC-441A-9ACE-A631D9A3EC37}"/>
+                <a16:creationId xmlns:a16="http://schemas.microsoft.com/office/drawing/2014/main" id="{9AAD7E76-2064-4DCB-A9DF-7C6EEB3C0F5D}"/>
               </a:ext>
             </a:extLst>
           </p:cNvPr>
@@ -3162,7 +3162,7 @@
     </p:spTree>
     <p:extLst>
       <p:ext uri="{BB962C8B-B14F-4D97-AF65-F5344CB8AC3E}">
-        <p14:creationId xmlns:p14="http://schemas.microsoft.com/office/powerpoint/2010/main" val="1474669966"/>
+        <p14:creationId xmlns:p14="http://schemas.microsoft.com/office/powerpoint/2010/main" val="717970566"/>
       </p:ext>
     </p:extLst>
   </p:cSld>
@@ -3193,7 +3193,7 @@
           <p:cNvPr id="1" name="">
             <a:extLst xmlns:a="http://schemas.openxmlformats.org/drawingml/2006/main">
               <a:ext uri="{FF2B5EF4-FFF2-40B4-BE49-F238E27FC236}">
-                <a16:creationId xmlns:a16="http://schemas.microsoft.com/office/drawing/2014/main" id="{1B04155D-D6CF-4278-A835-05A1D512D688}"/>
+                <a16:creationId xmlns:a16="http://schemas.microsoft.com/office/drawing/2014/main" id="{1EEDC3E8-904F-4739-A7F7-6539765C86CE}"/>
               </a:ext>
             </a:extLst>
           </p:cNvPr>
@@ -3243,7 +3243,7 @@
           <p:cNvPr id="2" name="">
             <a:extLst xmlns:a="http://schemas.openxmlformats.org/drawingml/2006/main">
               <a:ext uri="{FF2B5EF4-FFF2-40B4-BE49-F238E27FC236}">
-                <a16:creationId xmlns:a16="http://schemas.microsoft.com/office/drawing/2014/main" id="{8FF6121A-E948-4072-9000-E1937E60A557}"/>
+                <a16:creationId xmlns:a16="http://schemas.microsoft.com/office/drawing/2014/main" id="{5C5A6CF1-D826-4232-9519-FC47F27479DA}"/>
               </a:ext>
             </a:extLst>
           </p:cNvPr>
@@ -3293,7 +3293,7 @@
           <p:cNvPr id="3" name="">
             <a:extLst xmlns:a="http://schemas.openxmlformats.org/drawingml/2006/main">
               <a:ext uri="{FF2B5EF4-FFF2-40B4-BE49-F238E27FC236}">
-                <a16:creationId xmlns:a16="http://schemas.microsoft.com/office/drawing/2014/main" id="{9EA2D63F-34DD-430E-885A-1E5A47CD5170}"/>
+                <a16:creationId xmlns:a16="http://schemas.microsoft.com/office/drawing/2014/main" id="{52A00165-89A9-4229-A282-D378B32D8CA3}"/>
               </a:ext>
             </a:extLst>
           </p:cNvPr>
@@ -3326,7 +3326,7 @@
           <p:cNvPr id="4" name="">
             <a:extLst xmlns:a="http://schemas.openxmlformats.org/drawingml/2006/main">
               <a:ext uri="{FF2B5EF4-FFF2-40B4-BE49-F238E27FC236}">
-                <a16:creationId xmlns:a16="http://schemas.microsoft.com/office/drawing/2014/main" id="{33336336-AD03-4838-8B5D-15850047CBE3}"/>
+                <a16:creationId xmlns:a16="http://schemas.microsoft.com/office/drawing/2014/main" id="{9E28C072-260F-47A6-84B6-11691D287F40}"/>
               </a:ext>
             </a:extLst>
           </p:cNvPr>
@@ -3444,7 +3444,7 @@
           <p:cNvPr id="5" name="">
             <a:extLst xmlns:a="http://schemas.openxmlformats.org/drawingml/2006/main">
               <a:ext uri="{FF2B5EF4-FFF2-40B4-BE49-F238E27FC236}">
-                <a16:creationId xmlns:a16="http://schemas.microsoft.com/office/drawing/2014/main" id="{BB231E28-C9C3-4011-B8BB-7DA014FCA137}"/>
+                <a16:creationId xmlns:a16="http://schemas.microsoft.com/office/drawing/2014/main" id="{166D5F47-4C19-4290-AC6D-69632B9B5128}"/>
               </a:ext>
             </a:extLst>
           </p:cNvPr>
@@ -3484,7 +3484,7 @@
                   <a:srgbClr val="555555"/>
                 </a:solidFill>
               </a:rPr>
-              <a:t>Hướng phát triển: bổ sung dữ liệu chuẩn INRIA, hard negative mining và so sánh với YOLO.</a:t>
+              <a:t>Hướng phát triển: tăng số mẫu INRIA, hard negative mining và so sánh với YOLO.</a:t>
             </a:r>
           </a:p>
         </p:txBody>
@@ -3494,7 +3494,7 @@
           <p:cNvPr id="6" name="">
             <a:extLst xmlns:a="http://schemas.openxmlformats.org/drawingml/2006/main">
               <a:ext uri="{FF2B5EF4-FFF2-40B4-BE49-F238E27FC236}">
-                <a16:creationId xmlns:a16="http://schemas.microsoft.com/office/drawing/2014/main" id="{720A7E88-8875-4137-A166-6FA3EE1C1A61}"/>
+                <a16:creationId xmlns:a16="http://schemas.microsoft.com/office/drawing/2014/main" id="{8AFC7B02-3297-4C95-B218-B85957EF7999}"/>
               </a:ext>
             </a:extLst>
           </p:cNvPr>
@@ -3542,7 +3542,7 @@
     </p:spTree>
     <p:extLst>
       <p:ext uri="{BB962C8B-B14F-4D97-AF65-F5344CB8AC3E}">
-        <p14:creationId xmlns:p14="http://schemas.microsoft.com/office/powerpoint/2010/main" val="584085350"/>
+        <p14:creationId xmlns:p14="http://schemas.microsoft.com/office/powerpoint/2010/main" val="96155722"/>
       </p:ext>
     </p:extLst>
   </p:cSld>
@@ -3573,7 +3573,7 @@
           <p:cNvPr id="1" name="">
             <a:extLst xmlns:a="http://schemas.openxmlformats.org/drawingml/2006/main">
               <a:ext uri="{FF2B5EF4-FFF2-40B4-BE49-F238E27FC236}">
-                <a16:creationId xmlns:a16="http://schemas.microsoft.com/office/drawing/2014/main" id="{A7562995-4D55-4CFB-9FD5-C7D2A97BA4CD}"/>
+                <a16:creationId xmlns:a16="http://schemas.microsoft.com/office/drawing/2014/main" id="{FCB806B8-1ECD-4F1A-AE17-85DCB6A7A027}"/>
               </a:ext>
             </a:extLst>
           </p:cNvPr>
@@ -3623,7 +3623,7 @@
           <p:cNvPr id="2" name="">
             <a:extLst xmlns:a="http://schemas.openxmlformats.org/drawingml/2006/main">
               <a:ext uri="{FF2B5EF4-FFF2-40B4-BE49-F238E27FC236}">
-                <a16:creationId xmlns:a16="http://schemas.microsoft.com/office/drawing/2014/main" id="{3C134ADD-F8F1-449E-ACAD-13A4225E4833}"/>
+                <a16:creationId xmlns:a16="http://schemas.microsoft.com/office/drawing/2014/main" id="{AE8D1E83-C216-43B1-B0ED-6FFA3E3996DD}"/>
               </a:ext>
             </a:extLst>
           </p:cNvPr>
@@ -3673,7 +3673,7 @@
           <p:cNvPr id="3" name="">
             <a:extLst xmlns:a="http://schemas.openxmlformats.org/drawingml/2006/main">
               <a:ext uri="{FF2B5EF4-FFF2-40B4-BE49-F238E27FC236}">
-                <a16:creationId xmlns:a16="http://schemas.microsoft.com/office/drawing/2014/main" id="{55CAF508-62E4-489B-AA74-DC6AADEF8AE8}"/>
+                <a16:creationId xmlns:a16="http://schemas.microsoft.com/office/drawing/2014/main" id="{7814065B-3B2F-4603-8697-A4159C56B7C2}"/>
               </a:ext>
             </a:extLst>
           </p:cNvPr>
@@ -3706,7 +3706,7 @@
           <p:cNvPr id="4" name="">
             <a:extLst xmlns:a="http://schemas.openxmlformats.org/drawingml/2006/main">
               <a:ext uri="{FF2B5EF4-FFF2-40B4-BE49-F238E27FC236}">
-                <a16:creationId xmlns:a16="http://schemas.microsoft.com/office/drawing/2014/main" id="{9B1CBBF6-A36E-494C-8F49-420C9A83C424}"/>
+                <a16:creationId xmlns:a16="http://schemas.microsoft.com/office/drawing/2014/main" id="{0AA4327B-03F0-4317-AEB4-222CF02EC05B}"/>
               </a:ext>
             </a:extLst>
           </p:cNvPr>
@@ -3739,7 +3739,7 @@
           <p:cNvPr id="5" name="">
             <a:extLst xmlns:a="http://schemas.openxmlformats.org/drawingml/2006/main">
               <a:ext uri="{FF2B5EF4-FFF2-40B4-BE49-F238E27FC236}">
-                <a16:creationId xmlns:a16="http://schemas.microsoft.com/office/drawing/2014/main" id="{F11E0CF9-F443-4D1D-BD82-25DC14712456}"/>
+                <a16:creationId xmlns:a16="http://schemas.microsoft.com/office/drawing/2014/main" id="{2671F78D-8F51-438D-872B-BA87AEC93F55}"/>
               </a:ext>
             </a:extLst>
           </p:cNvPr>
@@ -3772,7 +3772,7 @@
           <p:cNvPr id="6" name="">
             <a:extLst xmlns:a="http://schemas.openxmlformats.org/drawingml/2006/main">
               <a:ext uri="{FF2B5EF4-FFF2-40B4-BE49-F238E27FC236}">
-                <a16:creationId xmlns:a16="http://schemas.microsoft.com/office/drawing/2014/main" id="{38AB803B-4291-4B7A-8CE4-F00933FF594E}"/>
+                <a16:creationId xmlns:a16="http://schemas.microsoft.com/office/drawing/2014/main" id="{12AD08E5-46F5-4577-A6BF-27A3FBB1D5A1}"/>
               </a:ext>
             </a:extLst>
           </p:cNvPr>
@@ -3822,7 +3822,7 @@
           <p:cNvPr id="7" name="">
             <a:extLst xmlns:a="http://schemas.openxmlformats.org/drawingml/2006/main">
               <a:ext uri="{FF2B5EF4-FFF2-40B4-BE49-F238E27FC236}">
-                <a16:creationId xmlns:a16="http://schemas.microsoft.com/office/drawing/2014/main" id="{8F2877C9-157B-434F-8ECE-4F1D876C5271}"/>
+                <a16:creationId xmlns:a16="http://schemas.microsoft.com/office/drawing/2014/main" id="{FABC3328-6CAF-4254-BB96-DDBE5F008730}"/>
               </a:ext>
             </a:extLst>
           </p:cNvPr>
@@ -3923,7 +3923,7 @@
           <p:cNvPr id="8" name="">
             <a:extLst xmlns:a="http://schemas.openxmlformats.org/drawingml/2006/main">
               <a:ext uri="{FF2B5EF4-FFF2-40B4-BE49-F238E27FC236}">
-                <a16:creationId xmlns:a16="http://schemas.microsoft.com/office/drawing/2014/main" id="{E13C1437-7ADB-463B-9A07-171F6E1C59B2}"/>
+                <a16:creationId xmlns:a16="http://schemas.microsoft.com/office/drawing/2014/main" id="{6B0829CA-4DDD-42E2-BA45-CE0FF2034D76}"/>
               </a:ext>
             </a:extLst>
           </p:cNvPr>
@@ -3973,7 +3973,7 @@
           <p:cNvPr id="9" name="">
             <a:extLst xmlns:a="http://schemas.openxmlformats.org/drawingml/2006/main">
               <a:ext uri="{FF2B5EF4-FFF2-40B4-BE49-F238E27FC236}">
-                <a16:creationId xmlns:a16="http://schemas.microsoft.com/office/drawing/2014/main" id="{8860CE3B-8AAE-4A0B-8BE7-439E5DF163EE}"/>
+                <a16:creationId xmlns:a16="http://schemas.microsoft.com/office/drawing/2014/main" id="{36000A64-1E07-45BF-8CD0-51617FCB1689}"/>
               </a:ext>
             </a:extLst>
           </p:cNvPr>
@@ -4030,7 +4030,7 @@
                   <a:srgbClr val="222222"/>
                 </a:solidFill>
               </a:rPr>
-              <a:t>- Dataset bootstrap 80 positive và 120 negative</a:t>
+              <a:t>- INRIA subset 300 positive và 300 negative</a:t>
             </a:r>
           </a:p>
           <a:p xmlns:a="http://schemas.openxmlformats.org/drawingml/2006/main">
@@ -4074,7 +4074,7 @@
           <p:cNvPr id="10" name="">
             <a:extLst xmlns:a="http://schemas.openxmlformats.org/drawingml/2006/main">
               <a:ext uri="{FF2B5EF4-FFF2-40B4-BE49-F238E27FC236}">
-                <a16:creationId xmlns:a16="http://schemas.microsoft.com/office/drawing/2014/main" id="{6136D769-D107-4DB3-BBDE-29842C1AEE3F}"/>
+                <a16:creationId xmlns:a16="http://schemas.microsoft.com/office/drawing/2014/main" id="{FAC4EF1A-C0FF-45EF-BDC9-B0FED97FB51F}"/>
               </a:ext>
             </a:extLst>
           </p:cNvPr>
@@ -4122,7 +4122,7 @@
     </p:spTree>
     <p:extLst>
       <p:ext uri="{BB962C8B-B14F-4D97-AF65-F5344CB8AC3E}">
-        <p14:creationId xmlns:p14="http://schemas.microsoft.com/office/powerpoint/2010/main" val="1287029299"/>
+        <p14:creationId xmlns:p14="http://schemas.microsoft.com/office/powerpoint/2010/main" val="1741902484"/>
       </p:ext>
     </p:extLst>
   </p:cSld>
@@ -4153,7 +4153,7 @@
           <p:cNvPr id="1" name="">
             <a:extLst xmlns:a="http://schemas.openxmlformats.org/drawingml/2006/main">
               <a:ext uri="{FF2B5EF4-FFF2-40B4-BE49-F238E27FC236}">
-                <a16:creationId xmlns:a16="http://schemas.microsoft.com/office/drawing/2014/main" id="{6671F337-DE46-401C-BFA2-73C785FE418F}"/>
+                <a16:creationId xmlns:a16="http://schemas.microsoft.com/office/drawing/2014/main" id="{AC88520B-3017-4DF8-90EE-6FA0832D72C5}"/>
               </a:ext>
             </a:extLst>
           </p:cNvPr>
@@ -4203,7 +4203,7 @@
           <p:cNvPr id="2" name="">
             <a:extLst xmlns:a="http://schemas.openxmlformats.org/drawingml/2006/main">
               <a:ext uri="{FF2B5EF4-FFF2-40B4-BE49-F238E27FC236}">
-                <a16:creationId xmlns:a16="http://schemas.microsoft.com/office/drawing/2014/main" id="{F1771C55-98EE-4813-B920-31F2068CF847}"/>
+                <a16:creationId xmlns:a16="http://schemas.microsoft.com/office/drawing/2014/main" id="{82EC4C24-5401-4FF3-8861-1914447AD9B8}"/>
               </a:ext>
             </a:extLst>
           </p:cNvPr>
@@ -4253,7 +4253,7 @@
           <p:cNvPr id="3" name="">
             <a:extLst xmlns:a="http://schemas.openxmlformats.org/drawingml/2006/main">
               <a:ext uri="{FF2B5EF4-FFF2-40B4-BE49-F238E27FC236}">
-                <a16:creationId xmlns:a16="http://schemas.microsoft.com/office/drawing/2014/main" id="{9B072ABA-FB17-40F6-B2B6-4B3413EC8332}"/>
+                <a16:creationId xmlns:a16="http://schemas.microsoft.com/office/drawing/2014/main" id="{108DD4FF-91A8-4730-97F3-760ABA5B820D}"/>
               </a:ext>
             </a:extLst>
           </p:cNvPr>
@@ -4286,7 +4286,7 @@
           <p:cNvPr id="4" name="">
             <a:extLst xmlns:a="http://schemas.openxmlformats.org/drawingml/2006/main">
               <a:ext uri="{FF2B5EF4-FFF2-40B4-BE49-F238E27FC236}">
-                <a16:creationId xmlns:a16="http://schemas.microsoft.com/office/drawing/2014/main" id="{3388EA92-0C59-47EA-BD45-C6140C249E9B}"/>
+                <a16:creationId xmlns:a16="http://schemas.microsoft.com/office/drawing/2014/main" id="{E7C196B5-829F-484A-B977-5980354AD974}"/>
               </a:ext>
             </a:extLst>
           </p:cNvPr>
@@ -4319,7 +4319,7 @@
           <p:cNvPr id="5" name="">
             <a:extLst xmlns:a="http://schemas.openxmlformats.org/drawingml/2006/main">
               <a:ext uri="{FF2B5EF4-FFF2-40B4-BE49-F238E27FC236}">
-                <a16:creationId xmlns:a16="http://schemas.microsoft.com/office/drawing/2014/main" id="{B6528597-04FF-4A93-BB0B-24AF0EE216EB}"/>
+                <a16:creationId xmlns:a16="http://schemas.microsoft.com/office/drawing/2014/main" id="{C013E532-98D3-411B-B2F6-B973E901CEC1}"/>
               </a:ext>
             </a:extLst>
           </p:cNvPr>
@@ -4369,7 +4369,7 @@
           <p:cNvPr id="6" name="">
             <a:extLst xmlns:a="http://schemas.openxmlformats.org/drawingml/2006/main">
               <a:ext uri="{FF2B5EF4-FFF2-40B4-BE49-F238E27FC236}">
-                <a16:creationId xmlns:a16="http://schemas.microsoft.com/office/drawing/2014/main" id="{75D13826-A3E5-4218-8412-EBBF16425FF2}"/>
+                <a16:creationId xmlns:a16="http://schemas.microsoft.com/office/drawing/2014/main" id="{B3B028E4-140E-4EC6-B2D1-B3DB1B4620DE}"/>
               </a:ext>
             </a:extLst>
           </p:cNvPr>
@@ -4402,7 +4402,7 @@
           <p:cNvPr id="7" name="">
             <a:extLst xmlns:a="http://schemas.openxmlformats.org/drawingml/2006/main">
               <a:ext uri="{FF2B5EF4-FFF2-40B4-BE49-F238E27FC236}">
-                <a16:creationId xmlns:a16="http://schemas.microsoft.com/office/drawing/2014/main" id="{962FEB53-7EC9-4041-829B-CDC4E127E372}"/>
+                <a16:creationId xmlns:a16="http://schemas.microsoft.com/office/drawing/2014/main" id="{C69F03CE-528C-46D1-BC86-31022616A17F}"/>
               </a:ext>
             </a:extLst>
           </p:cNvPr>
@@ -4452,7 +4452,7 @@
           <p:cNvPr id="8" name="">
             <a:extLst xmlns:a="http://schemas.openxmlformats.org/drawingml/2006/main">
               <a:ext uri="{FF2B5EF4-FFF2-40B4-BE49-F238E27FC236}">
-                <a16:creationId xmlns:a16="http://schemas.microsoft.com/office/drawing/2014/main" id="{D6553560-B5BF-4E24-B3E3-609F628F0AB2}"/>
+                <a16:creationId xmlns:a16="http://schemas.microsoft.com/office/drawing/2014/main" id="{1DAF158B-97A8-4418-A834-2BCF9E001FB4}"/>
               </a:ext>
             </a:extLst>
           </p:cNvPr>
@@ -4485,7 +4485,7 @@
           <p:cNvPr id="9" name="">
             <a:extLst xmlns:a="http://schemas.openxmlformats.org/drawingml/2006/main">
               <a:ext uri="{FF2B5EF4-FFF2-40B4-BE49-F238E27FC236}">
-                <a16:creationId xmlns:a16="http://schemas.microsoft.com/office/drawing/2014/main" id="{80F5320B-31B8-4B8C-A574-E36FCBC9CE15}"/>
+                <a16:creationId xmlns:a16="http://schemas.microsoft.com/office/drawing/2014/main" id="{980B8AE7-5B5C-4C6E-BA7D-C4ADAFE07975}"/>
               </a:ext>
             </a:extLst>
           </p:cNvPr>
@@ -4535,7 +4535,7 @@
           <p:cNvPr id="10" name="">
             <a:extLst xmlns:a="http://schemas.openxmlformats.org/drawingml/2006/main">
               <a:ext uri="{FF2B5EF4-FFF2-40B4-BE49-F238E27FC236}">
-                <a16:creationId xmlns:a16="http://schemas.microsoft.com/office/drawing/2014/main" id="{8E1642F6-383F-4433-99E4-AA15179E659F}"/>
+                <a16:creationId xmlns:a16="http://schemas.microsoft.com/office/drawing/2014/main" id="{08A5B337-3FFF-4578-9A2A-8C34E39119C9}"/>
               </a:ext>
             </a:extLst>
           </p:cNvPr>
@@ -4568,7 +4568,7 @@
           <p:cNvPr id="11" name="">
             <a:extLst xmlns:a="http://schemas.openxmlformats.org/drawingml/2006/main">
               <a:ext uri="{FF2B5EF4-FFF2-40B4-BE49-F238E27FC236}">
-                <a16:creationId xmlns:a16="http://schemas.microsoft.com/office/drawing/2014/main" id="{FBD57BFC-337E-445E-ABCB-C4ED610C1564}"/>
+                <a16:creationId xmlns:a16="http://schemas.microsoft.com/office/drawing/2014/main" id="{964AF76A-F47B-45AF-9FD1-160BA34A26B9}"/>
               </a:ext>
             </a:extLst>
           </p:cNvPr>
@@ -4618,7 +4618,7 @@
           <p:cNvPr id="12" name="">
             <a:extLst xmlns:a="http://schemas.openxmlformats.org/drawingml/2006/main">
               <a:ext uri="{FF2B5EF4-FFF2-40B4-BE49-F238E27FC236}">
-                <a16:creationId xmlns:a16="http://schemas.microsoft.com/office/drawing/2014/main" id="{B5EB25D6-F724-41D7-910B-401666E9EE48}"/>
+                <a16:creationId xmlns:a16="http://schemas.microsoft.com/office/drawing/2014/main" id="{AF4FFBCC-2644-4D12-BEBB-B56CFF3DD543}"/>
               </a:ext>
             </a:extLst>
           </p:cNvPr>
@@ -4651,7 +4651,7 @@
           <p:cNvPr id="13" name="">
             <a:extLst xmlns:a="http://schemas.openxmlformats.org/drawingml/2006/main">
               <a:ext uri="{FF2B5EF4-FFF2-40B4-BE49-F238E27FC236}">
-                <a16:creationId xmlns:a16="http://schemas.microsoft.com/office/drawing/2014/main" id="{3A04A656-9B23-453D-871A-1B4E8D140B88}"/>
+                <a16:creationId xmlns:a16="http://schemas.microsoft.com/office/drawing/2014/main" id="{29AB01E3-2AD0-4E32-8FE0-3ED45C1049E4}"/>
               </a:ext>
             </a:extLst>
           </p:cNvPr>
@@ -4701,7 +4701,7 @@
           <p:cNvPr id="14" name="">
             <a:extLst xmlns:a="http://schemas.openxmlformats.org/drawingml/2006/main">
               <a:ext uri="{FF2B5EF4-FFF2-40B4-BE49-F238E27FC236}">
-                <a16:creationId xmlns:a16="http://schemas.microsoft.com/office/drawing/2014/main" id="{6E3A97A8-43BC-4A87-A80F-06D058F255EC}"/>
+                <a16:creationId xmlns:a16="http://schemas.microsoft.com/office/drawing/2014/main" id="{F1A8610F-A1BA-48B6-8BD8-F705525CCCFB}"/>
               </a:ext>
             </a:extLst>
           </p:cNvPr>
@@ -4734,7 +4734,7 @@
           <p:cNvPr id="15" name="">
             <a:extLst xmlns:a="http://schemas.openxmlformats.org/drawingml/2006/main">
               <a:ext uri="{FF2B5EF4-FFF2-40B4-BE49-F238E27FC236}">
-                <a16:creationId xmlns:a16="http://schemas.microsoft.com/office/drawing/2014/main" id="{0C8279B0-A255-4C5C-9569-3E052A23A0E0}"/>
+                <a16:creationId xmlns:a16="http://schemas.microsoft.com/office/drawing/2014/main" id="{860E48E8-BBC0-46F1-948B-9A5755799E74}"/>
               </a:ext>
             </a:extLst>
           </p:cNvPr>
@@ -4784,7 +4784,7 @@
           <p:cNvPr id="16" name="">
             <a:extLst xmlns:a="http://schemas.openxmlformats.org/drawingml/2006/main">
               <a:ext uri="{FF2B5EF4-FFF2-40B4-BE49-F238E27FC236}">
-                <a16:creationId xmlns:a16="http://schemas.microsoft.com/office/drawing/2014/main" id="{3127728A-C63C-4650-96B5-41509A22FB00}"/>
+                <a16:creationId xmlns:a16="http://schemas.microsoft.com/office/drawing/2014/main" id="{FA5D391F-80D1-4998-AE81-BACBC26BC8B0}"/>
               </a:ext>
             </a:extLst>
           </p:cNvPr>
@@ -4817,7 +4817,7 @@
           <p:cNvPr id="17" name="">
             <a:extLst xmlns:a="http://schemas.openxmlformats.org/drawingml/2006/main">
               <a:ext uri="{FF2B5EF4-FFF2-40B4-BE49-F238E27FC236}">
-                <a16:creationId xmlns:a16="http://schemas.microsoft.com/office/drawing/2014/main" id="{ECF53F27-0062-493C-8BBF-53927EE66D61}"/>
+                <a16:creationId xmlns:a16="http://schemas.microsoft.com/office/drawing/2014/main" id="{9C5BD33D-69ED-409E-A8C3-712F2F1DBE5A}"/>
               </a:ext>
             </a:extLst>
           </p:cNvPr>
@@ -4867,7 +4867,7 @@
           <p:cNvPr id="18" name="">
             <a:extLst xmlns:a="http://schemas.openxmlformats.org/drawingml/2006/main">
               <a:ext uri="{FF2B5EF4-FFF2-40B4-BE49-F238E27FC236}">
-                <a16:creationId xmlns:a16="http://schemas.microsoft.com/office/drawing/2014/main" id="{2F23D0A1-2FE1-4459-83BD-458DA559619A}"/>
+                <a16:creationId xmlns:a16="http://schemas.microsoft.com/office/drawing/2014/main" id="{2C5EF60E-C2EA-449B-B5D2-5ECC73010030}"/>
               </a:ext>
             </a:extLst>
           </p:cNvPr>
@@ -4917,7 +4917,7 @@
           <p:cNvPr id="19" name="">
             <a:extLst xmlns:a="http://schemas.openxmlformats.org/drawingml/2006/main">
               <a:ext uri="{FF2B5EF4-FFF2-40B4-BE49-F238E27FC236}">
-                <a16:creationId xmlns:a16="http://schemas.microsoft.com/office/drawing/2014/main" id="{F85493A4-1B35-4F5B-AF8E-F8EA8014447E}"/>
+                <a16:creationId xmlns:a16="http://schemas.microsoft.com/office/drawing/2014/main" id="{88D0F303-5BA8-489A-A589-345E8FC8758A}"/>
               </a:ext>
             </a:extLst>
           </p:cNvPr>
@@ -4965,7 +4965,7 @@
     </p:spTree>
     <p:extLst>
       <p:ext uri="{BB962C8B-B14F-4D97-AF65-F5344CB8AC3E}">
-        <p14:creationId xmlns:p14="http://schemas.microsoft.com/office/powerpoint/2010/main" val="1977888655"/>
+        <p14:creationId xmlns:p14="http://schemas.microsoft.com/office/powerpoint/2010/main" val="1957577787"/>
       </p:ext>
     </p:extLst>
   </p:cSld>
@@ -4996,7 +4996,7 @@
           <p:cNvPr id="1" name="">
             <a:extLst xmlns:a="http://schemas.openxmlformats.org/drawingml/2006/main">
               <a:ext uri="{FF2B5EF4-FFF2-40B4-BE49-F238E27FC236}">
-                <a16:creationId xmlns:a16="http://schemas.microsoft.com/office/drawing/2014/main" id="{7553C2BB-EE9E-4B09-9987-75968C942757}"/>
+                <a16:creationId xmlns:a16="http://schemas.microsoft.com/office/drawing/2014/main" id="{12489F71-8227-4366-9971-EB0A5F7FAF0F}"/>
               </a:ext>
             </a:extLst>
           </p:cNvPr>
@@ -5046,7 +5046,7 @@
           <p:cNvPr id="2" name="">
             <a:extLst xmlns:a="http://schemas.openxmlformats.org/drawingml/2006/main">
               <a:ext uri="{FF2B5EF4-FFF2-40B4-BE49-F238E27FC236}">
-                <a16:creationId xmlns:a16="http://schemas.microsoft.com/office/drawing/2014/main" id="{243C6E01-DC5A-4E97-8C50-EED1213B724B}"/>
+                <a16:creationId xmlns:a16="http://schemas.microsoft.com/office/drawing/2014/main" id="{B290D188-93E5-4953-9CFD-04FD6DBEFE69}"/>
               </a:ext>
             </a:extLst>
           </p:cNvPr>
@@ -5096,7 +5096,7 @@
           <p:cNvPr id="3" name="">
             <a:extLst xmlns:a="http://schemas.openxmlformats.org/drawingml/2006/main">
               <a:ext uri="{FF2B5EF4-FFF2-40B4-BE49-F238E27FC236}">
-                <a16:creationId xmlns:a16="http://schemas.microsoft.com/office/drawing/2014/main" id="{A6E0BC88-4BDB-4ECF-911D-904965DE9957}"/>
+                <a16:creationId xmlns:a16="http://schemas.microsoft.com/office/drawing/2014/main" id="{B20E0383-9D52-4AB3-B580-2E7375C38840}"/>
               </a:ext>
             </a:extLst>
           </p:cNvPr>
@@ -5133,7 +5133,7 @@
           <p:nvPr/>
         </p:nvPicPr>
         <p:blipFill>
-          <a:blip xmlns:r="http://schemas.openxmlformats.org/officeDocument/2006/relationships" xmlns:a="http://schemas.openxmlformats.org/drawingml/2006/main" r:embed="R0dfe787a15e044f1"/>
+          <a:blip xmlns:r="http://schemas.openxmlformats.org/officeDocument/2006/relationships" xmlns:a="http://schemas.openxmlformats.org/drawingml/2006/main" r:embed="R89fea6d03c384b05"/>
           <a:stretch xmlns:a="http://schemas.openxmlformats.org/drawingml/2006/main"/>
         </p:blipFill>
         <p:spPr>
@@ -5155,7 +5155,7 @@
           <p:nvPr/>
         </p:nvPicPr>
         <p:blipFill>
-          <a:blip xmlns:r="http://schemas.openxmlformats.org/officeDocument/2006/relationships" xmlns:a="http://schemas.openxmlformats.org/drawingml/2006/main" r:embed="R23776df4727d48cd"/>
+          <a:blip xmlns:r="http://schemas.openxmlformats.org/officeDocument/2006/relationships" xmlns:a="http://schemas.openxmlformats.org/drawingml/2006/main" r:embed="R31e8a974b63d4202"/>
           <a:stretch xmlns:a="http://schemas.openxmlformats.org/drawingml/2006/main"/>
         </p:blipFill>
         <p:spPr>
@@ -5173,7 +5173,7 @@
           <p:cNvPr id="6" name="">
             <a:extLst xmlns:a="http://schemas.openxmlformats.org/drawingml/2006/main">
               <a:ext uri="{FF2B5EF4-FFF2-40B4-BE49-F238E27FC236}">
-                <a16:creationId xmlns:a16="http://schemas.microsoft.com/office/drawing/2014/main" id="{82274301-5A3E-4103-8FCF-139863055718}"/>
+                <a16:creationId xmlns:a16="http://schemas.microsoft.com/office/drawing/2014/main" id="{00C0F7EF-2CFD-43FD-B07C-A5CFBB2235FA}"/>
               </a:ext>
             </a:extLst>
           </p:cNvPr>
@@ -5223,7 +5223,7 @@
           <p:cNvPr id="7" name="">
             <a:extLst xmlns:a="http://schemas.openxmlformats.org/drawingml/2006/main">
               <a:ext uri="{FF2B5EF4-FFF2-40B4-BE49-F238E27FC236}">
-                <a16:creationId xmlns:a16="http://schemas.microsoft.com/office/drawing/2014/main" id="{A8FE690E-E03F-4E47-B17D-78DBD20D896C}"/>
+                <a16:creationId xmlns:a16="http://schemas.microsoft.com/office/drawing/2014/main" id="{62F8FB0B-F4E1-49E0-B518-5319F433FF23}"/>
               </a:ext>
             </a:extLst>
           </p:cNvPr>
@@ -5273,7 +5273,7 @@
           <p:cNvPr id="8" name="">
             <a:extLst xmlns:a="http://schemas.openxmlformats.org/drawingml/2006/main">
               <a:ext uri="{FF2B5EF4-FFF2-40B4-BE49-F238E27FC236}">
-                <a16:creationId xmlns:a16="http://schemas.microsoft.com/office/drawing/2014/main" id="{9CFFEBB5-383E-407F-BCBE-CD95E9F2D2C7}"/>
+                <a16:creationId xmlns:a16="http://schemas.microsoft.com/office/drawing/2014/main" id="{4A17324C-B634-4C11-8F6D-9F63078BC661}"/>
               </a:ext>
             </a:extLst>
           </p:cNvPr>
@@ -5321,7 +5321,7 @@
     </p:spTree>
     <p:extLst>
       <p:ext uri="{BB962C8B-B14F-4D97-AF65-F5344CB8AC3E}">
-        <p14:creationId xmlns:p14="http://schemas.microsoft.com/office/powerpoint/2010/main" val="459204163"/>
+        <p14:creationId xmlns:p14="http://schemas.microsoft.com/office/powerpoint/2010/main" val="1031088475"/>
       </p:ext>
     </p:extLst>
   </p:cSld>
@@ -5352,7 +5352,7 @@
           <p:cNvPr id="1" name="">
             <a:extLst xmlns:a="http://schemas.openxmlformats.org/drawingml/2006/main">
               <a:ext uri="{FF2B5EF4-FFF2-40B4-BE49-F238E27FC236}">
-                <a16:creationId xmlns:a16="http://schemas.microsoft.com/office/drawing/2014/main" id="{9E398098-EF35-40B3-AD63-7CDA596245C5}"/>
+                <a16:creationId xmlns:a16="http://schemas.microsoft.com/office/drawing/2014/main" id="{9D0B3BA5-0E9D-49B5-9F5F-7C1281202F70}"/>
               </a:ext>
             </a:extLst>
           </p:cNvPr>
@@ -5402,7 +5402,7 @@
           <p:cNvPr id="2" name="">
             <a:extLst xmlns:a="http://schemas.openxmlformats.org/drawingml/2006/main">
               <a:ext uri="{FF2B5EF4-FFF2-40B4-BE49-F238E27FC236}">
-                <a16:creationId xmlns:a16="http://schemas.microsoft.com/office/drawing/2014/main" id="{995D8AA8-7F83-4CBC-9328-2DB7CD638FBE}"/>
+                <a16:creationId xmlns:a16="http://schemas.microsoft.com/office/drawing/2014/main" id="{54150159-C984-457F-BB5D-3D76CC824AEA}"/>
               </a:ext>
             </a:extLst>
           </p:cNvPr>
@@ -5452,7 +5452,7 @@
           <p:cNvPr id="3" name="">
             <a:extLst xmlns:a="http://schemas.openxmlformats.org/drawingml/2006/main">
               <a:ext uri="{FF2B5EF4-FFF2-40B4-BE49-F238E27FC236}">
-                <a16:creationId xmlns:a16="http://schemas.microsoft.com/office/drawing/2014/main" id="{1F19F796-7378-4040-A640-F5DCB47316B9}"/>
+                <a16:creationId xmlns:a16="http://schemas.microsoft.com/office/drawing/2014/main" id="{7CA4AE26-E5CE-4AFC-B0C9-D07446D62EF1}"/>
               </a:ext>
             </a:extLst>
           </p:cNvPr>
@@ -5489,7 +5489,7 @@
           <p:nvPr/>
         </p:nvPicPr>
         <p:blipFill>
-          <a:blip xmlns:r="http://schemas.openxmlformats.org/officeDocument/2006/relationships" xmlns:a="http://schemas.openxmlformats.org/drawingml/2006/main" r:embed="R42be37e0464e4eed"/>
+          <a:blip xmlns:r="http://schemas.openxmlformats.org/officeDocument/2006/relationships" xmlns:a="http://schemas.openxmlformats.org/drawingml/2006/main" r:embed="R8ea2436e96d54cce"/>
           <a:stretch xmlns:a="http://schemas.openxmlformats.org/drawingml/2006/main"/>
         </p:blipFill>
         <p:spPr>
@@ -5507,7 +5507,7 @@
           <p:cNvPr id="5" name="">
             <a:extLst xmlns:a="http://schemas.openxmlformats.org/drawingml/2006/main">
               <a:ext uri="{FF2B5EF4-FFF2-40B4-BE49-F238E27FC236}">
-                <a16:creationId xmlns:a16="http://schemas.microsoft.com/office/drawing/2014/main" id="{0EE0EB1E-21EB-4984-A4D4-BEF7CDE6153D}"/>
+                <a16:creationId xmlns:a16="http://schemas.microsoft.com/office/drawing/2014/main" id="{AC7EF189-3921-4998-B554-C6C6D8FDEBDA}"/>
               </a:ext>
             </a:extLst>
           </p:cNvPr>
@@ -5625,7 +5625,7 @@
           <p:cNvPr id="6" name="">
             <a:extLst xmlns:a="http://schemas.openxmlformats.org/drawingml/2006/main">
               <a:ext uri="{FF2B5EF4-FFF2-40B4-BE49-F238E27FC236}">
-                <a16:creationId xmlns:a16="http://schemas.microsoft.com/office/drawing/2014/main" id="{EA8325CB-72A3-41F4-A8FC-8F9610D9683A}"/>
+                <a16:creationId xmlns:a16="http://schemas.microsoft.com/office/drawing/2014/main" id="{8B993966-E103-4359-BDDE-C3B53BBC82C9}"/>
               </a:ext>
             </a:extLst>
           </p:cNvPr>
@@ -5673,7 +5673,7 @@
     </p:spTree>
     <p:extLst>
       <p:ext uri="{BB962C8B-B14F-4D97-AF65-F5344CB8AC3E}">
-        <p14:creationId xmlns:p14="http://schemas.microsoft.com/office/powerpoint/2010/main" val="827246527"/>
+        <p14:creationId xmlns:p14="http://schemas.microsoft.com/office/powerpoint/2010/main" val="972616415"/>
       </p:ext>
     </p:extLst>
   </p:cSld>
@@ -5704,7 +5704,7 @@
           <p:cNvPr id="1" name="">
             <a:extLst xmlns:a="http://schemas.openxmlformats.org/drawingml/2006/main">
               <a:ext uri="{FF2B5EF4-FFF2-40B4-BE49-F238E27FC236}">
-                <a16:creationId xmlns:a16="http://schemas.microsoft.com/office/drawing/2014/main" id="{18FECF94-01FA-4A88-8FB9-9A8DDEDC1A9E}"/>
+                <a16:creationId xmlns:a16="http://schemas.microsoft.com/office/drawing/2014/main" id="{4FC0CEF4-D747-47EA-B973-E8D87AA4755E}"/>
               </a:ext>
             </a:extLst>
           </p:cNvPr>
@@ -5754,7 +5754,7 @@
           <p:cNvPr id="2" name="">
             <a:extLst xmlns:a="http://schemas.openxmlformats.org/drawingml/2006/main">
               <a:ext uri="{FF2B5EF4-FFF2-40B4-BE49-F238E27FC236}">
-                <a16:creationId xmlns:a16="http://schemas.microsoft.com/office/drawing/2014/main" id="{6B731242-14E3-4699-B7E4-C902760E92BA}"/>
+                <a16:creationId xmlns:a16="http://schemas.microsoft.com/office/drawing/2014/main" id="{C19407F5-84BB-47A7-9413-23FE1B8DACC3}"/>
               </a:ext>
             </a:extLst>
           </p:cNvPr>
@@ -5804,7 +5804,7 @@
           <p:cNvPr id="3" name="">
             <a:extLst xmlns:a="http://schemas.openxmlformats.org/drawingml/2006/main">
               <a:ext uri="{FF2B5EF4-FFF2-40B4-BE49-F238E27FC236}">
-                <a16:creationId xmlns:a16="http://schemas.microsoft.com/office/drawing/2014/main" id="{9C1DC29F-D44C-4BAB-ABA6-3A2D2614214D}"/>
+                <a16:creationId xmlns:a16="http://schemas.microsoft.com/office/drawing/2014/main" id="{8DA5613F-4D40-46B1-B002-6ACBECF5B26D}"/>
               </a:ext>
             </a:extLst>
           </p:cNvPr>
@@ -5837,7 +5837,7 @@
           <p:cNvPr id="4" name="">
             <a:extLst xmlns:a="http://schemas.openxmlformats.org/drawingml/2006/main">
               <a:ext uri="{FF2B5EF4-FFF2-40B4-BE49-F238E27FC236}">
-                <a16:creationId xmlns:a16="http://schemas.microsoft.com/office/drawing/2014/main" id="{FD086EFB-4A87-48F3-86DE-D9EEB1E4306C}"/>
+                <a16:creationId xmlns:a16="http://schemas.microsoft.com/office/drawing/2014/main" id="{40A6DE48-B44B-4CF9-9068-3844A5E10899}"/>
               </a:ext>
             </a:extLst>
           </p:cNvPr>
@@ -5870,7 +5870,7 @@
           <p:cNvPr id="5" name="">
             <a:extLst xmlns:a="http://schemas.openxmlformats.org/drawingml/2006/main">
               <a:ext uri="{FF2B5EF4-FFF2-40B4-BE49-F238E27FC236}">
-                <a16:creationId xmlns:a16="http://schemas.microsoft.com/office/drawing/2014/main" id="{C1A0A836-B55A-4742-977C-F831DB1D8EB1}"/>
+                <a16:creationId xmlns:a16="http://schemas.microsoft.com/office/drawing/2014/main" id="{B4BC4DBF-F8F6-4B34-8300-B31B7D749845}"/>
               </a:ext>
             </a:extLst>
           </p:cNvPr>
@@ -5920,7 +5920,7 @@
           <p:cNvPr id="6" name="">
             <a:extLst xmlns:a="http://schemas.openxmlformats.org/drawingml/2006/main">
               <a:ext uri="{FF2B5EF4-FFF2-40B4-BE49-F238E27FC236}">
-                <a16:creationId xmlns:a16="http://schemas.microsoft.com/office/drawing/2014/main" id="{A7046545-EB22-4965-90A8-9039828991AE}"/>
+                <a16:creationId xmlns:a16="http://schemas.microsoft.com/office/drawing/2014/main" id="{F667F1A0-D8E2-4048-8472-FF404B55F65E}"/>
               </a:ext>
             </a:extLst>
           </p:cNvPr>
@@ -5970,7 +5970,7 @@
           <p:cNvPr id="7" name="">
             <a:extLst xmlns:a="http://schemas.openxmlformats.org/drawingml/2006/main">
               <a:ext uri="{FF2B5EF4-FFF2-40B4-BE49-F238E27FC236}">
-                <a16:creationId xmlns:a16="http://schemas.microsoft.com/office/drawing/2014/main" id="{97C096D2-79DE-4504-9A0F-D385A725006B}"/>
+                <a16:creationId xmlns:a16="http://schemas.microsoft.com/office/drawing/2014/main" id="{74F3998E-9F73-4351-ADA1-3690E6D2413D}"/>
               </a:ext>
             </a:extLst>
           </p:cNvPr>
@@ -6071,7 +6071,7 @@
           <p:cNvPr id="8" name="">
             <a:extLst xmlns:a="http://schemas.openxmlformats.org/drawingml/2006/main">
               <a:ext uri="{FF2B5EF4-FFF2-40B4-BE49-F238E27FC236}">
-                <a16:creationId xmlns:a16="http://schemas.microsoft.com/office/drawing/2014/main" id="{C0F63943-DC9A-4899-A664-1226F2624452}"/>
+                <a16:creationId xmlns:a16="http://schemas.microsoft.com/office/drawing/2014/main" id="{91A80781-578A-4B54-93DB-7205CAB741F4}"/>
               </a:ext>
             </a:extLst>
           </p:cNvPr>
@@ -6119,7 +6119,7 @@
     </p:spTree>
     <p:extLst>
       <p:ext uri="{BB962C8B-B14F-4D97-AF65-F5344CB8AC3E}">
-        <p14:creationId xmlns:p14="http://schemas.microsoft.com/office/powerpoint/2010/main" val="1761205637"/>
+        <p14:creationId xmlns:p14="http://schemas.microsoft.com/office/powerpoint/2010/main" val="1377023916"/>
       </p:ext>
     </p:extLst>
   </p:cSld>
@@ -6150,7 +6150,7 @@
           <p:cNvPr id="1" name="">
             <a:extLst xmlns:a="http://schemas.openxmlformats.org/drawingml/2006/main">
               <a:ext uri="{FF2B5EF4-FFF2-40B4-BE49-F238E27FC236}">
-                <a16:creationId xmlns:a16="http://schemas.microsoft.com/office/drawing/2014/main" id="{04BA2D03-3BE0-46B3-994B-3CDF3A454FDD}"/>
+                <a16:creationId xmlns:a16="http://schemas.microsoft.com/office/drawing/2014/main" id="{181D0C66-AB7A-4819-9393-373B104E6842}"/>
               </a:ext>
             </a:extLst>
           </p:cNvPr>
@@ -6200,7 +6200,7 @@
           <p:cNvPr id="2" name="">
             <a:extLst xmlns:a="http://schemas.openxmlformats.org/drawingml/2006/main">
               <a:ext uri="{FF2B5EF4-FFF2-40B4-BE49-F238E27FC236}">
-                <a16:creationId xmlns:a16="http://schemas.microsoft.com/office/drawing/2014/main" id="{873AF49E-CD48-47DF-A956-1A08E7E5AB25}"/>
+                <a16:creationId xmlns:a16="http://schemas.microsoft.com/office/drawing/2014/main" id="{A4EBF790-4FB8-4689-8452-DEE0E4274824}"/>
               </a:ext>
             </a:extLst>
           </p:cNvPr>
@@ -6250,7 +6250,7 @@
           <p:cNvPr id="3" name="">
             <a:extLst xmlns:a="http://schemas.openxmlformats.org/drawingml/2006/main">
               <a:ext uri="{FF2B5EF4-FFF2-40B4-BE49-F238E27FC236}">
-                <a16:creationId xmlns:a16="http://schemas.microsoft.com/office/drawing/2014/main" id="{49ADA85A-D6B6-486D-9D43-A53D2D4BE336}"/>
+                <a16:creationId xmlns:a16="http://schemas.microsoft.com/office/drawing/2014/main" id="{2E70CAFF-6279-4697-9302-11855593A33F}"/>
               </a:ext>
             </a:extLst>
           </p:cNvPr>
@@ -6283,7 +6283,7 @@
           <p:cNvPr id="4" name="">
             <a:extLst xmlns:a="http://schemas.openxmlformats.org/drawingml/2006/main">
               <a:ext uri="{FF2B5EF4-FFF2-40B4-BE49-F238E27FC236}">
-                <a16:creationId xmlns:a16="http://schemas.microsoft.com/office/drawing/2014/main" id="{2E419D07-8106-441E-A9A9-F855F813EDEE}"/>
+                <a16:creationId xmlns:a16="http://schemas.microsoft.com/office/drawing/2014/main" id="{870A6B8F-7127-47BF-9CAA-06A5210C666A}"/>
               </a:ext>
             </a:extLst>
           </p:cNvPr>
@@ -6316,7 +6316,7 @@
           <p:cNvPr id="5" name="">
             <a:extLst xmlns:a="http://schemas.openxmlformats.org/drawingml/2006/main">
               <a:ext uri="{FF2B5EF4-FFF2-40B4-BE49-F238E27FC236}">
-                <a16:creationId xmlns:a16="http://schemas.microsoft.com/office/drawing/2014/main" id="{7F58DFB4-41E6-4121-904E-7F28A67C332A}"/>
+                <a16:creationId xmlns:a16="http://schemas.microsoft.com/office/drawing/2014/main" id="{A74C69D9-16A1-4094-933F-F9BE7A6E1F74}"/>
               </a:ext>
             </a:extLst>
           </p:cNvPr>
@@ -6349,7 +6349,7 @@
           <p:cNvPr id="6" name="">
             <a:extLst xmlns:a="http://schemas.openxmlformats.org/drawingml/2006/main">
               <a:ext uri="{FF2B5EF4-FFF2-40B4-BE49-F238E27FC236}">
-                <a16:creationId xmlns:a16="http://schemas.microsoft.com/office/drawing/2014/main" id="{A5602006-F040-4722-B23F-0C1A09E1CD9B}"/>
+                <a16:creationId xmlns:a16="http://schemas.microsoft.com/office/drawing/2014/main" id="{2997830C-3FD6-4572-8CD4-58A3B569BFB1}"/>
               </a:ext>
             </a:extLst>
           </p:cNvPr>
@@ -6399,7 +6399,7 @@
           <p:cNvPr id="7" name="">
             <a:extLst xmlns:a="http://schemas.openxmlformats.org/drawingml/2006/main">
               <a:ext uri="{FF2B5EF4-FFF2-40B4-BE49-F238E27FC236}">
-                <a16:creationId xmlns:a16="http://schemas.microsoft.com/office/drawing/2014/main" id="{365440A6-CCFA-4867-A823-19416D2202AB}"/>
+                <a16:creationId xmlns:a16="http://schemas.microsoft.com/office/drawing/2014/main" id="{925E65B5-E3F2-4CAF-A5BA-8445235FCF07}"/>
               </a:ext>
             </a:extLst>
           </p:cNvPr>
@@ -6500,7 +6500,7 @@
           <p:cNvPr id="8" name="">
             <a:extLst xmlns:a="http://schemas.openxmlformats.org/drawingml/2006/main">
               <a:ext uri="{FF2B5EF4-FFF2-40B4-BE49-F238E27FC236}">
-                <a16:creationId xmlns:a16="http://schemas.microsoft.com/office/drawing/2014/main" id="{5A3E613A-F9DB-4AA6-9E5F-A515D4768D96}"/>
+                <a16:creationId xmlns:a16="http://schemas.microsoft.com/office/drawing/2014/main" id="{714442BB-7AE5-474C-8F7A-AE4D6C7093ED}"/>
               </a:ext>
             </a:extLst>
           </p:cNvPr>
@@ -6550,7 +6550,7 @@
           <p:cNvPr id="9" name="">
             <a:extLst xmlns:a="http://schemas.openxmlformats.org/drawingml/2006/main">
               <a:ext uri="{FF2B5EF4-FFF2-40B4-BE49-F238E27FC236}">
-                <a16:creationId xmlns:a16="http://schemas.microsoft.com/office/drawing/2014/main" id="{36B646A2-68BE-46F0-9817-8769E4195E9B}"/>
+                <a16:creationId xmlns:a16="http://schemas.microsoft.com/office/drawing/2014/main" id="{751BA628-C1E9-4729-A25E-F159C26AFEEA}"/>
               </a:ext>
             </a:extLst>
           </p:cNvPr>
@@ -6590,7 +6590,7 @@
                   <a:srgbClr val="222222"/>
                 </a:solidFill>
               </a:rPr>
-              <a:t>- Train từ positive/negative trong project</a:t>
+              <a:t>- Train từ INRIA subset ngoài video demo</a:t>
             </a:r>
           </a:p>
           <a:p xmlns:a="http://schemas.openxmlformats.org/drawingml/2006/main">
@@ -6651,7 +6651,7 @@
           <p:cNvPr id="10" name="">
             <a:extLst xmlns:a="http://schemas.openxmlformats.org/drawingml/2006/main">
               <a:ext uri="{FF2B5EF4-FFF2-40B4-BE49-F238E27FC236}">
-                <a16:creationId xmlns:a16="http://schemas.microsoft.com/office/drawing/2014/main" id="{C28AC38B-B78C-4158-BB9C-F74197076955}"/>
+                <a16:creationId xmlns:a16="http://schemas.microsoft.com/office/drawing/2014/main" id="{944C4D10-A322-4D17-8C86-F87E58B046A4}"/>
               </a:ext>
             </a:extLst>
           </p:cNvPr>
@@ -6699,7 +6699,7 @@
     </p:spTree>
     <p:extLst>
       <p:ext uri="{BB962C8B-B14F-4D97-AF65-F5344CB8AC3E}">
-        <p14:creationId xmlns:p14="http://schemas.microsoft.com/office/powerpoint/2010/main" val="719700966"/>
+        <p14:creationId xmlns:p14="http://schemas.microsoft.com/office/powerpoint/2010/main" val="1375770739"/>
       </p:ext>
     </p:extLst>
   </p:cSld>
@@ -6730,7 +6730,7 @@
           <p:cNvPr id="1" name="">
             <a:extLst xmlns:a="http://schemas.openxmlformats.org/drawingml/2006/main">
               <a:ext uri="{FF2B5EF4-FFF2-40B4-BE49-F238E27FC236}">
-                <a16:creationId xmlns:a16="http://schemas.microsoft.com/office/drawing/2014/main" id="{C7C60E66-F022-4650-8264-F37F0D1D5776}"/>
+                <a16:creationId xmlns:a16="http://schemas.microsoft.com/office/drawing/2014/main" id="{AF2EDB5A-4CF5-43C3-A3AF-26BF1770753D}"/>
               </a:ext>
             </a:extLst>
           </p:cNvPr>
@@ -6780,7 +6780,7 @@
           <p:cNvPr id="2" name="">
             <a:extLst xmlns:a="http://schemas.openxmlformats.org/drawingml/2006/main">
               <a:ext uri="{FF2B5EF4-FFF2-40B4-BE49-F238E27FC236}">
-                <a16:creationId xmlns:a16="http://schemas.microsoft.com/office/drawing/2014/main" id="{A6D70FE0-A7E4-4F3A-BF7F-2BB9DD59BB76}"/>
+                <a16:creationId xmlns:a16="http://schemas.microsoft.com/office/drawing/2014/main" id="{7905CC39-EB53-432C-AB9C-79502107326D}"/>
               </a:ext>
             </a:extLst>
           </p:cNvPr>
@@ -6820,7 +6820,7 @@
                   <a:srgbClr val="000000"/>
                 </a:solidFill>
               </a:rPr>
-              <a:t>Dataset bootstrap đủ để train và giải thích quy trình học máy</a:t>
+              <a:t>INRIA subset giúp custom SVM không phụ thuộc video demo</a:t>
             </a:r>
           </a:p>
         </p:txBody>
@@ -6830,7 +6830,7 @@
           <p:cNvPr id="3" name="">
             <a:extLst xmlns:a="http://schemas.openxmlformats.org/drawingml/2006/main">
               <a:ext uri="{FF2B5EF4-FFF2-40B4-BE49-F238E27FC236}">
-                <a16:creationId xmlns:a16="http://schemas.microsoft.com/office/drawing/2014/main" id="{78C848B9-54B3-4B09-ADB3-D0EA3A6123FB}"/>
+                <a16:creationId xmlns:a16="http://schemas.microsoft.com/office/drawing/2014/main" id="{8201062B-7478-4D37-AC37-F38A3BFF6715}"/>
               </a:ext>
             </a:extLst>
           </p:cNvPr>
@@ -6863,7 +6863,7 @@
           <p:cNvPr id="4" name="">
             <a:extLst xmlns:a="http://schemas.openxmlformats.org/drawingml/2006/main">
               <a:ext uri="{FF2B5EF4-FFF2-40B4-BE49-F238E27FC236}">
-                <a16:creationId xmlns:a16="http://schemas.microsoft.com/office/drawing/2014/main" id="{F86C5612-3EF3-44CB-98C7-B51DD6B91566}"/>
+                <a16:creationId xmlns:a16="http://schemas.microsoft.com/office/drawing/2014/main" id="{CE74E1D8-78F7-416C-B7F3-3E030AF185E3}"/>
               </a:ext>
             </a:extLst>
           </p:cNvPr>
@@ -6896,7 +6896,7 @@
           <p:cNvPr id="5" name="">
             <a:extLst xmlns:a="http://schemas.openxmlformats.org/drawingml/2006/main">
               <a:ext uri="{FF2B5EF4-FFF2-40B4-BE49-F238E27FC236}">
-                <a16:creationId xmlns:a16="http://schemas.microsoft.com/office/drawing/2014/main" id="{956EDD8F-A921-4454-A42F-B37C29316815}"/>
+                <a16:creationId xmlns:a16="http://schemas.microsoft.com/office/drawing/2014/main" id="{9FBA879B-5A17-4E36-B470-6E081C690CBD}"/>
               </a:ext>
             </a:extLst>
           </p:cNvPr>
@@ -6936,7 +6936,7 @@
                   <a:srgbClr val="000000"/>
                 </a:solidFill>
               </a:rPr>
-              <a:t>80</a:t>
+              <a:t>300</a:t>
             </a:r>
           </a:p>
         </p:txBody>
@@ -6946,7 +6946,7 @@
           <p:cNvPr id="6" name="">
             <a:extLst xmlns:a="http://schemas.openxmlformats.org/drawingml/2006/main">
               <a:ext uri="{FF2B5EF4-FFF2-40B4-BE49-F238E27FC236}">
-                <a16:creationId xmlns:a16="http://schemas.microsoft.com/office/drawing/2014/main" id="{4A0AAE8E-D407-42E8-9C7B-72AABB50A756}"/>
+                <a16:creationId xmlns:a16="http://schemas.microsoft.com/office/drawing/2014/main" id="{9A3B158A-6EDC-4AAA-BD65-223658A91B16}"/>
               </a:ext>
             </a:extLst>
           </p:cNvPr>
@@ -6996,7 +6996,7 @@
           <p:cNvPr id="7" name="">
             <a:extLst xmlns:a="http://schemas.openxmlformats.org/drawingml/2006/main">
               <a:ext uri="{FF2B5EF4-FFF2-40B4-BE49-F238E27FC236}">
-                <a16:creationId xmlns:a16="http://schemas.microsoft.com/office/drawing/2014/main" id="{01BCB29D-1A1E-4124-A5CB-7271D44B55A8}"/>
+                <a16:creationId xmlns:a16="http://schemas.microsoft.com/office/drawing/2014/main" id="{BEA9925C-CCE1-472C-918F-CB88D81609BE}"/>
               </a:ext>
             </a:extLst>
           </p:cNvPr>
@@ -7036,7 +7036,7 @@
                   <a:srgbClr val="555555"/>
                 </a:solidFill>
               </a:rPr>
-              <a:t>crop người đi bộ</a:t>
+              <a:t>ảnh pedestrian INRIA</a:t>
             </a:r>
           </a:p>
         </p:txBody>
@@ -7046,7 +7046,7 @@
           <p:cNvPr id="8" name="">
             <a:extLst xmlns:a="http://schemas.openxmlformats.org/drawingml/2006/main">
               <a:ext uri="{FF2B5EF4-FFF2-40B4-BE49-F238E27FC236}">
-                <a16:creationId xmlns:a16="http://schemas.microsoft.com/office/drawing/2014/main" id="{0405743D-8B95-42DF-BB66-636B21509C29}"/>
+                <a16:creationId xmlns:a16="http://schemas.microsoft.com/office/drawing/2014/main" id="{829A2912-5D10-4FB3-9649-C8CE69E68EED}"/>
               </a:ext>
             </a:extLst>
           </p:cNvPr>
@@ -7079,7 +7079,7 @@
           <p:cNvPr id="9" name="">
             <a:extLst xmlns:a="http://schemas.openxmlformats.org/drawingml/2006/main">
               <a:ext uri="{FF2B5EF4-FFF2-40B4-BE49-F238E27FC236}">
-                <a16:creationId xmlns:a16="http://schemas.microsoft.com/office/drawing/2014/main" id="{622961FE-CCAF-41BE-8FEB-4CE1F01CB29D}"/>
+                <a16:creationId xmlns:a16="http://schemas.microsoft.com/office/drawing/2014/main" id="{FD78E27C-F05B-44AC-8D44-0A085A8C3DCF}"/>
               </a:ext>
             </a:extLst>
           </p:cNvPr>
@@ -7119,7 +7119,7 @@
                   <a:srgbClr val="000000"/>
                 </a:solidFill>
               </a:rPr>
-              <a:t>120</a:t>
+              <a:t>300</a:t>
             </a:r>
           </a:p>
         </p:txBody>
@@ -7129,7 +7129,7 @@
           <p:cNvPr id="10" name="">
             <a:extLst xmlns:a="http://schemas.openxmlformats.org/drawingml/2006/main">
               <a:ext uri="{FF2B5EF4-FFF2-40B4-BE49-F238E27FC236}">
-                <a16:creationId xmlns:a16="http://schemas.microsoft.com/office/drawing/2014/main" id="{647A4FE1-4F97-4CDE-BDB1-CE93D96D1B41}"/>
+                <a16:creationId xmlns:a16="http://schemas.microsoft.com/office/drawing/2014/main" id="{A5EC8F81-C29E-4E7F-9ABA-6B296B6DB891}"/>
               </a:ext>
             </a:extLst>
           </p:cNvPr>
@@ -7179,7 +7179,7 @@
           <p:cNvPr id="11" name="">
             <a:extLst xmlns:a="http://schemas.openxmlformats.org/drawingml/2006/main">
               <a:ext uri="{FF2B5EF4-FFF2-40B4-BE49-F238E27FC236}">
-                <a16:creationId xmlns:a16="http://schemas.microsoft.com/office/drawing/2014/main" id="{C31885C4-14A1-457C-A815-745BA2B2B0A5}"/>
+                <a16:creationId xmlns:a16="http://schemas.microsoft.com/office/drawing/2014/main" id="{DFA34F7E-ABBC-4526-AEFC-8ED46FF05F73}"/>
               </a:ext>
             </a:extLst>
           </p:cNvPr>
@@ -7219,7 +7219,7 @@
                   <a:srgbClr val="555555"/>
                 </a:solidFill>
               </a:rPr>
-              <a:t>vùng nền không người</a:t>
+              <a:t>patch nền không người</a:t>
             </a:r>
           </a:p>
         </p:txBody>
@@ -7229,7 +7229,7 @@
           <p:cNvPr id="12" name="">
             <a:extLst xmlns:a="http://schemas.openxmlformats.org/drawingml/2006/main">
               <a:ext uri="{FF2B5EF4-FFF2-40B4-BE49-F238E27FC236}">
-                <a16:creationId xmlns:a16="http://schemas.microsoft.com/office/drawing/2014/main" id="{D88EAE54-94C6-435C-91F4-1F6FA2C51936}"/>
+                <a16:creationId xmlns:a16="http://schemas.microsoft.com/office/drawing/2014/main" id="{E8CEDAC7-AF0F-4818-A7AB-96DFED984B6D}"/>
               </a:ext>
             </a:extLst>
           </p:cNvPr>
@@ -7262,7 +7262,7 @@
           <p:cNvPr id="13" name="">
             <a:extLst xmlns:a="http://schemas.openxmlformats.org/drawingml/2006/main">
               <a:ext uri="{FF2B5EF4-FFF2-40B4-BE49-F238E27FC236}">
-                <a16:creationId xmlns:a16="http://schemas.microsoft.com/office/drawing/2014/main" id="{6ED6DA7D-313E-44E3-BE39-7FBDA17AD906}"/>
+                <a16:creationId xmlns:a16="http://schemas.microsoft.com/office/drawing/2014/main" id="{4394BE4C-FC4C-4814-ADA3-8BCB4384F7D3}"/>
               </a:ext>
             </a:extLst>
           </p:cNvPr>
@@ -7312,7 +7312,7 @@
           <p:cNvPr id="14" name="">
             <a:extLst xmlns:a="http://schemas.openxmlformats.org/drawingml/2006/main">
               <a:ext uri="{FF2B5EF4-FFF2-40B4-BE49-F238E27FC236}">
-                <a16:creationId xmlns:a16="http://schemas.microsoft.com/office/drawing/2014/main" id="{B9027C53-EDA2-4D33-AAED-BEFCA0AC7D48}"/>
+                <a16:creationId xmlns:a16="http://schemas.microsoft.com/office/drawing/2014/main" id="{D0C838C3-BE23-41DE-8875-1975EB899AB2}"/>
               </a:ext>
             </a:extLst>
           </p:cNvPr>
@@ -7362,7 +7362,7 @@
           <p:cNvPr id="15" name="">
             <a:extLst xmlns:a="http://schemas.openxmlformats.org/drawingml/2006/main">
               <a:ext uri="{FF2B5EF4-FFF2-40B4-BE49-F238E27FC236}">
-                <a16:creationId xmlns:a16="http://schemas.microsoft.com/office/drawing/2014/main" id="{06F55392-E210-4CD2-95CA-FBAC389F884B}"/>
+                <a16:creationId xmlns:a16="http://schemas.microsoft.com/office/drawing/2014/main" id="{10029F7F-8EAA-4577-96E8-7022A98C25CD}"/>
               </a:ext>
             </a:extLst>
           </p:cNvPr>
@@ -7412,7 +7412,7 @@
           <p:cNvPr id="16" name="">
             <a:extLst xmlns:a="http://schemas.openxmlformats.org/drawingml/2006/main">
               <a:ext uri="{FF2B5EF4-FFF2-40B4-BE49-F238E27FC236}">
-                <a16:creationId xmlns:a16="http://schemas.microsoft.com/office/drawing/2014/main" id="{78AE82AE-6768-4D86-A49A-0611FECC80AE}"/>
+                <a16:creationId xmlns:a16="http://schemas.microsoft.com/office/drawing/2014/main" id="{3D98BCD1-CCB1-4C8F-AE31-7FE3C8BD88EE}"/>
               </a:ext>
             </a:extLst>
           </p:cNvPr>
@@ -7445,7 +7445,7 @@
           <p:cNvPr id="17" name="">
             <a:extLst xmlns:a="http://schemas.openxmlformats.org/drawingml/2006/main">
               <a:ext uri="{FF2B5EF4-FFF2-40B4-BE49-F238E27FC236}">
-                <a16:creationId xmlns:a16="http://schemas.microsoft.com/office/drawing/2014/main" id="{9F214B1B-689B-4FB8-9A26-07246F6222A0}"/>
+                <a16:creationId xmlns:a16="http://schemas.microsoft.com/office/drawing/2014/main" id="{52439CB2-2B9D-4887-AA43-A87DABE27954}"/>
               </a:ext>
             </a:extLst>
           </p:cNvPr>
@@ -7485,7 +7485,7 @@
                   <a:srgbClr val="000000"/>
                 </a:solidFill>
               </a:rPr>
-              <a:t>200</a:t>
+              <a:t>600</a:t>
             </a:r>
           </a:p>
         </p:txBody>
@@ -7495,7 +7495,7 @@
           <p:cNvPr id="18" name="">
             <a:extLst xmlns:a="http://schemas.openxmlformats.org/drawingml/2006/main">
               <a:ext uri="{FF2B5EF4-FFF2-40B4-BE49-F238E27FC236}">
-                <a16:creationId xmlns:a16="http://schemas.microsoft.com/office/drawing/2014/main" id="{68A69548-00D9-4022-B744-77B8686C0774}"/>
+                <a16:creationId xmlns:a16="http://schemas.microsoft.com/office/drawing/2014/main" id="{02233831-3EC2-4A21-A213-5AE720F4A149}"/>
               </a:ext>
             </a:extLst>
           </p:cNvPr>
@@ -7545,7 +7545,7 @@
           <p:cNvPr id="19" name="">
             <a:extLst xmlns:a="http://schemas.openxmlformats.org/drawingml/2006/main">
               <a:ext uri="{FF2B5EF4-FFF2-40B4-BE49-F238E27FC236}">
-                <a16:creationId xmlns:a16="http://schemas.microsoft.com/office/drawing/2014/main" id="{C79B1F51-1EF7-405A-A32D-39AF54B64C59}"/>
+                <a16:creationId xmlns:a16="http://schemas.microsoft.com/office/drawing/2014/main" id="{3554DE33-0A19-44C6-85E9-FF55BA1A84E2}"/>
               </a:ext>
             </a:extLst>
           </p:cNvPr>
@@ -7595,7 +7595,7 @@
           <p:cNvPr id="20" name="">
             <a:extLst xmlns:a="http://schemas.openxmlformats.org/drawingml/2006/main">
               <a:ext uri="{FF2B5EF4-FFF2-40B4-BE49-F238E27FC236}">
-                <a16:creationId xmlns:a16="http://schemas.microsoft.com/office/drawing/2014/main" id="{D49CAA1B-B8CA-4096-A060-8B6C6B88CBA8}"/>
+                <a16:creationId xmlns:a16="http://schemas.microsoft.com/office/drawing/2014/main" id="{84CFF33D-5713-4B49-BB91-16CC2537749F}"/>
               </a:ext>
             </a:extLst>
           </p:cNvPr>
@@ -7635,7 +7635,7 @@
                   <a:srgbClr val="222222"/>
                 </a:solidFill>
               </a:rPr>
-              <a:t>Dataset được tạo từ walking.mp4 bằng script bootstrap, sau đó train custom Linear SVM bằng HOG feature.</a:t>
+              <a:t>Dataset train được tải từ INRIA Person mirror trên Hugging Face; walking.mp4 chỉ còn là video demo.</a:t>
             </a:r>
           </a:p>
         </p:txBody>
@@ -7645,7 +7645,7 @@
           <p:cNvPr id="21" name="">
             <a:extLst xmlns:a="http://schemas.openxmlformats.org/drawingml/2006/main">
               <a:ext uri="{FF2B5EF4-FFF2-40B4-BE49-F238E27FC236}">
-                <a16:creationId xmlns:a16="http://schemas.microsoft.com/office/drawing/2014/main" id="{283D0B3C-DC09-4BD7-A7FF-699DF57363CE}"/>
+                <a16:creationId xmlns:a16="http://schemas.microsoft.com/office/drawing/2014/main" id="{FAC58C09-747F-495B-A011-004CB9E7FE71}"/>
               </a:ext>
             </a:extLst>
           </p:cNvPr>
@@ -7693,7 +7693,7 @@
     </p:spTree>
     <p:extLst>
       <p:ext uri="{BB962C8B-B14F-4D97-AF65-F5344CB8AC3E}">
-        <p14:creationId xmlns:p14="http://schemas.microsoft.com/office/powerpoint/2010/main" val="103391880"/>
+        <p14:creationId xmlns:p14="http://schemas.microsoft.com/office/powerpoint/2010/main" val="1518176948"/>
       </p:ext>
     </p:extLst>
   </p:cSld>
@@ -7724,7 +7724,7 @@
           <p:cNvPr id="1" name="">
             <a:extLst xmlns:a="http://schemas.openxmlformats.org/drawingml/2006/main">
               <a:ext uri="{FF2B5EF4-FFF2-40B4-BE49-F238E27FC236}">
-                <a16:creationId xmlns:a16="http://schemas.microsoft.com/office/drawing/2014/main" id="{B4930B69-C00F-4279-AFCE-E096100D43C7}"/>
+                <a16:creationId xmlns:a16="http://schemas.microsoft.com/office/drawing/2014/main" id="{09E0CBAF-10E1-4A81-A4B0-8DD9BCDD07AA}"/>
               </a:ext>
             </a:extLst>
           </p:cNvPr>
@@ -7774,7 +7774,7 @@
           <p:cNvPr id="2" name="">
             <a:extLst xmlns:a="http://schemas.openxmlformats.org/drawingml/2006/main">
               <a:ext uri="{FF2B5EF4-FFF2-40B4-BE49-F238E27FC236}">
-                <a16:creationId xmlns:a16="http://schemas.microsoft.com/office/drawing/2014/main" id="{4A1229E5-7DE9-4216-90F6-7CA36562FAED}"/>
+                <a16:creationId xmlns:a16="http://schemas.microsoft.com/office/drawing/2014/main" id="{E86F8AA5-48C4-484C-85C8-6743346E7532}"/>
               </a:ext>
             </a:extLst>
           </p:cNvPr>
@@ -7814,7 +7814,7 @@
                   <a:srgbClr val="000000"/>
                 </a:solidFill>
               </a:rPr>
-              <a:t>Custom SVM đạt kết quả tốt trên dataset bootstrap</a:t>
+              <a:t>Custom SVM đạt kết quả tốt trên INRIA subset</a:t>
             </a:r>
           </a:p>
         </p:txBody>
@@ -7824,7 +7824,7 @@
           <p:cNvPr id="3" name="">
             <a:extLst xmlns:a="http://schemas.openxmlformats.org/drawingml/2006/main">
               <a:ext uri="{FF2B5EF4-FFF2-40B4-BE49-F238E27FC236}">
-                <a16:creationId xmlns:a16="http://schemas.microsoft.com/office/drawing/2014/main" id="{AE3E70B8-541E-4E3A-B20D-B3E958F0C14D}"/>
+                <a16:creationId xmlns:a16="http://schemas.microsoft.com/office/drawing/2014/main" id="{79C8F4E6-4623-4D62-8C0F-16F9A40F10BE}"/>
               </a:ext>
             </a:extLst>
           </p:cNvPr>
@@ -7857,7 +7857,7 @@
           <p:cNvPr id="4" name="">
             <a:extLst xmlns:a="http://schemas.openxmlformats.org/drawingml/2006/main">
               <a:ext uri="{FF2B5EF4-FFF2-40B4-BE49-F238E27FC236}">
-                <a16:creationId xmlns:a16="http://schemas.microsoft.com/office/drawing/2014/main" id="{6275A659-9EBA-4735-A665-C1F314338A98}"/>
+                <a16:creationId xmlns:a16="http://schemas.microsoft.com/office/drawing/2014/main" id="{0C981C2B-7CD8-4BC3-AB3C-F4B788D60D95}"/>
               </a:ext>
             </a:extLst>
           </p:cNvPr>
@@ -7890,7 +7890,7 @@
           <p:cNvPr id="5" name="">
             <a:extLst xmlns:a="http://schemas.openxmlformats.org/drawingml/2006/main">
               <a:ext uri="{FF2B5EF4-FFF2-40B4-BE49-F238E27FC236}">
-                <a16:creationId xmlns:a16="http://schemas.microsoft.com/office/drawing/2014/main" id="{E0D3B54C-8CFF-46BD-AADF-8875F7218A42}"/>
+                <a16:creationId xmlns:a16="http://schemas.microsoft.com/office/drawing/2014/main" id="{09B46DF4-B0A6-47E2-B351-2ACB66532115}"/>
               </a:ext>
             </a:extLst>
           </p:cNvPr>
@@ -7930,7 +7930,7 @@
                   <a:srgbClr val="000000"/>
                 </a:solidFill>
               </a:rPr>
-              <a:t>0.95</a:t>
+              <a:t>0.967</a:t>
             </a:r>
           </a:p>
         </p:txBody>
@@ -7940,7 +7940,7 @@
           <p:cNvPr id="6" name="">
             <a:extLst xmlns:a="http://schemas.openxmlformats.org/drawingml/2006/main">
               <a:ext uri="{FF2B5EF4-FFF2-40B4-BE49-F238E27FC236}">
-                <a16:creationId xmlns:a16="http://schemas.microsoft.com/office/drawing/2014/main" id="{108DB087-D55E-4770-8974-11CBCE472DE0}"/>
+                <a16:creationId xmlns:a16="http://schemas.microsoft.com/office/drawing/2014/main" id="{1801FCA3-6361-4032-9498-FF455B967EFD}"/>
               </a:ext>
             </a:extLst>
           </p:cNvPr>
@@ -7990,7 +7990,7 @@
           <p:cNvPr id="7" name="">
             <a:extLst xmlns:a="http://schemas.openxmlformats.org/drawingml/2006/main">
               <a:ext uri="{FF2B5EF4-FFF2-40B4-BE49-F238E27FC236}">
-                <a16:creationId xmlns:a16="http://schemas.microsoft.com/office/drawing/2014/main" id="{E9495C9D-09C6-4B11-A494-D9B9DAEC8B5F}"/>
+                <a16:creationId xmlns:a16="http://schemas.microsoft.com/office/drawing/2014/main" id="{DF1B36C5-2701-42F3-9AA7-510F6099EBC7}"/>
               </a:ext>
             </a:extLst>
           </p:cNvPr>
@@ -8030,7 +8030,7 @@
                   <a:srgbClr val="555555"/>
                 </a:solidFill>
               </a:rPr>
-              <a:t>40 mẫu test</a:t>
+              <a:t>120 mẫu test</a:t>
             </a:r>
           </a:p>
         </p:txBody>
@@ -8040,7 +8040,7 @@
           <p:cNvPr id="8" name="">
             <a:extLst xmlns:a="http://schemas.openxmlformats.org/drawingml/2006/main">
               <a:ext uri="{FF2B5EF4-FFF2-40B4-BE49-F238E27FC236}">
-                <a16:creationId xmlns:a16="http://schemas.microsoft.com/office/drawing/2014/main" id="{959A9EB3-6EBB-4F24-8455-5F3DCEEBB44F}"/>
+                <a16:creationId xmlns:a16="http://schemas.microsoft.com/office/drawing/2014/main" id="{D653F0F6-A7C3-4599-BE54-AE6B0BF2584E}"/>
               </a:ext>
             </a:extLst>
           </p:cNvPr>
@@ -8073,7 +8073,7 @@
           <p:cNvPr id="9" name="">
             <a:extLst xmlns:a="http://schemas.openxmlformats.org/drawingml/2006/main">
               <a:ext uri="{FF2B5EF4-FFF2-40B4-BE49-F238E27FC236}">
-                <a16:creationId xmlns:a16="http://schemas.microsoft.com/office/drawing/2014/main" id="{FBB27F59-4C12-41F9-B940-23CB444AA0FF}"/>
+                <a16:creationId xmlns:a16="http://schemas.microsoft.com/office/drawing/2014/main" id="{3E108E73-11A3-46F5-97C3-EF58448263AB}"/>
               </a:ext>
             </a:extLst>
           </p:cNvPr>
@@ -8113,7 +8113,7 @@
                   <a:srgbClr val="000000"/>
                 </a:solidFill>
               </a:rPr>
-              <a:t>0.99</a:t>
+              <a:t>0.993</a:t>
             </a:r>
           </a:p>
         </p:txBody>
@@ -8123,7 +8123,7 @@
           <p:cNvPr id="10" name="">
             <a:extLst xmlns:a="http://schemas.openxmlformats.org/drawingml/2006/main">
               <a:ext uri="{FF2B5EF4-FFF2-40B4-BE49-F238E27FC236}">
-                <a16:creationId xmlns:a16="http://schemas.microsoft.com/office/drawing/2014/main" id="{5029225B-52A4-488E-B2D4-00BFCE45AF0E}"/>
+                <a16:creationId xmlns:a16="http://schemas.microsoft.com/office/drawing/2014/main" id="{9B5FBAAF-D1EF-4885-939C-105064A4A756}"/>
               </a:ext>
             </a:extLst>
           </p:cNvPr>
@@ -8173,7 +8173,7 @@
           <p:cNvPr id="11" name="">
             <a:extLst xmlns:a="http://schemas.openxmlformats.org/drawingml/2006/main">
               <a:ext uri="{FF2B5EF4-FFF2-40B4-BE49-F238E27FC236}">
-                <a16:creationId xmlns:a16="http://schemas.microsoft.com/office/drawing/2014/main" id="{629AF061-E8CD-463E-870C-31F55941AB08}"/>
+                <a16:creationId xmlns:a16="http://schemas.microsoft.com/office/drawing/2014/main" id="{737F8087-570A-4556-A1AD-F9BF5C821435}"/>
               </a:ext>
             </a:extLst>
           </p:cNvPr>
@@ -8213,7 +8213,7 @@
                   <a:srgbClr val="555555"/>
                 </a:solidFill>
               </a:rPr>
-              <a:t>200 mẫu toàn dataset</a:t>
+              <a:t>600 mẫu toàn dataset</a:t>
             </a:r>
           </a:p>
         </p:txBody>
@@ -8223,7 +8223,7 @@
           <p:cNvPr id="12" name="">
             <a:extLst xmlns:a="http://schemas.openxmlformats.org/drawingml/2006/main">
               <a:ext uri="{FF2B5EF4-FFF2-40B4-BE49-F238E27FC236}">
-                <a16:creationId xmlns:a16="http://schemas.microsoft.com/office/drawing/2014/main" id="{04D1480D-0F06-4C95-9B96-398BD8A30CDE}"/>
+                <a16:creationId xmlns:a16="http://schemas.microsoft.com/office/drawing/2014/main" id="{60645D91-9E67-483A-9A4A-09349C168AB1}"/>
               </a:ext>
             </a:extLst>
           </p:cNvPr>
@@ -8256,7 +8256,7 @@
           <p:cNvPr id="13" name="">
             <a:extLst xmlns:a="http://schemas.openxmlformats.org/drawingml/2006/main">
               <a:ext uri="{FF2B5EF4-FFF2-40B4-BE49-F238E27FC236}">
-                <a16:creationId xmlns:a16="http://schemas.microsoft.com/office/drawing/2014/main" id="{5CDE5AAA-F5D0-4CF4-B7BB-DF1B4D9F2296}"/>
+                <a16:creationId xmlns:a16="http://schemas.microsoft.com/office/drawing/2014/main" id="{2C6A60B7-CE1B-4B9A-B8EF-68039A1BD7B6}"/>
               </a:ext>
             </a:extLst>
           </p:cNvPr>
@@ -8306,7 +8306,7 @@
           <p:cNvPr id="14" name="">
             <a:extLst xmlns:a="http://schemas.openxmlformats.org/drawingml/2006/main">
               <a:ext uri="{FF2B5EF4-FFF2-40B4-BE49-F238E27FC236}">
-                <a16:creationId xmlns:a16="http://schemas.microsoft.com/office/drawing/2014/main" id="{E0EB53EA-E52D-4FED-BB7F-3FCEE99543EE}"/>
+                <a16:creationId xmlns:a16="http://schemas.microsoft.com/office/drawing/2014/main" id="{5E7BF3CE-959A-4725-941D-8C980749D1B1}"/>
               </a:ext>
             </a:extLst>
           </p:cNvPr>
@@ -8346,7 +8346,7 @@
                   <a:srgbClr val="222222"/>
                 </a:solidFill>
               </a:rPr>
-              <a:t>Test: [[22, 2], [0, 16]]</a:t>
+              <a:t>Test: [[59, 1], [3, 57]]</a:t>
             </a:r>
           </a:p>
           <a:p xmlns:a="http://schemas.openxmlformats.org/drawingml/2006/main">
@@ -8363,7 +8363,7 @@
                   <a:srgbClr val="222222"/>
                 </a:solidFill>
               </a:rPr>
-              <a:t>Full: [[118, 2], [0, 80]]</a:t>
+              <a:t>Full: [[299, 1], [3, 297]]</a:t>
             </a:r>
           </a:p>
         </p:txBody>
@@ -8373,7 +8373,7 @@
           <p:cNvPr id="15" name="">
             <a:extLst xmlns:a="http://schemas.openxmlformats.org/drawingml/2006/main">
               <a:ext uri="{FF2B5EF4-FFF2-40B4-BE49-F238E27FC236}">
-                <a16:creationId xmlns:a16="http://schemas.microsoft.com/office/drawing/2014/main" id="{0331622D-7CDD-4ED4-A578-5BA058BC1ED6}"/>
+                <a16:creationId xmlns:a16="http://schemas.microsoft.com/office/drawing/2014/main" id="{97B1B3DE-EF00-44DA-9B56-A8A65B7CC80F}"/>
               </a:ext>
             </a:extLst>
           </p:cNvPr>
@@ -8413,7 +8413,7 @@
                   <a:srgbClr val="222222"/>
                 </a:solidFill>
               </a:rPr>
-              <a:t>Ý nghĩa: model không bỏ sót positive trong dataset, nhưng vẫn có một số negative bị nhầm thành person.</a:t>
+              <a:t>Ý nghĩa: model đã học từ nguồn ngoài video demo; lỗi còn lại chủ yếu là vài nhầm lẫn giữa nền nhiều cạnh và dáng người.</a:t>
             </a:r>
           </a:p>
         </p:txBody>
@@ -8423,7 +8423,7 @@
           <p:cNvPr id="16" name="">
             <a:extLst xmlns:a="http://schemas.openxmlformats.org/drawingml/2006/main">
               <a:ext uri="{FF2B5EF4-FFF2-40B4-BE49-F238E27FC236}">
-                <a16:creationId xmlns:a16="http://schemas.microsoft.com/office/drawing/2014/main" id="{21A7B488-71C0-416D-83C7-82C3A82EACD0}"/>
+                <a16:creationId xmlns:a16="http://schemas.microsoft.com/office/drawing/2014/main" id="{7C262D21-196F-4208-ACC3-38ED210C2567}"/>
               </a:ext>
             </a:extLst>
           </p:cNvPr>
@@ -8471,7 +8471,7 @@
     </p:spTree>
     <p:extLst>
       <p:ext uri="{BB962C8B-B14F-4D97-AF65-F5344CB8AC3E}">
-        <p14:creationId xmlns:p14="http://schemas.microsoft.com/office/powerpoint/2010/main" val="1448258036"/>
+        <p14:creationId xmlns:p14="http://schemas.microsoft.com/office/powerpoint/2010/main" val="1664545237"/>
       </p:ext>
     </p:extLst>
   </p:cSld>

</xml_diff>